<commit_message>
initial commit of thesis presentation
</commit_message>
<xml_diff>
--- a/meeting_notes/thesis.pptx
+++ b/meeting_notes/thesis.pptx
@@ -5,10 +5,10 @@
     <p:sldMasterId id="2147483662" r:id="rId12"/>
   </p:sldMasterIdLst>
   <p:notesMasterIdLst>
-    <p:notesMasterId r:id="rId22"/>
+    <p:notesMasterId r:id="rId23"/>
   </p:notesMasterIdLst>
   <p:handoutMasterIdLst>
-    <p:handoutMasterId r:id="rId23"/>
+    <p:handoutMasterId r:id="rId24"/>
   </p:handoutMasterIdLst>
   <p:sldIdLst>
     <p:sldId id="256" r:id="rId13"/>
@@ -18,13 +18,14 @@
     <p:sldId id="262" r:id="rId17"/>
     <p:sldId id="263" r:id="rId18"/>
     <p:sldId id="267" r:id="rId19"/>
-    <p:sldId id="264" r:id="rId20"/>
-    <p:sldId id="266" r:id="rId21"/>
+    <p:sldId id="266" r:id="rId20"/>
+    <p:sldId id="268" r:id="rId21"/>
+    <p:sldId id="269" r:id="rId22"/>
   </p:sldIdLst>
   <p:sldSz cx="12190413" cy="6858000"/>
   <p:notesSz cx="6858000" cy="9144000"/>
   <p:custDataLst>
-    <p:tags r:id="rId24"/>
+    <p:tags r:id="rId25"/>
   </p:custDataLst>
   <p:defaultTextStyle>
     <a:defPPr>
@@ -163,8 +164,9 @@
             <p14:sldId id="262"/>
             <p14:sldId id="263"/>
             <p14:sldId id="267"/>
-            <p14:sldId id="264"/>
             <p14:sldId id="266"/>
+            <p14:sldId id="268"/>
+            <p14:sldId id="269"/>
           </p14:sldIdLst>
         </p14:section>
       </p14:sectionLst>
@@ -9247,6 +9249,239 @@
 </p:sld>
 </file>
 
+<file path=ppt/slides/slide10.xml><?xml version="1.0" encoding="utf-8"?>
+<p:sld xmlns:a="http://schemas.openxmlformats.org/drawingml/2006/main" xmlns:r="http://schemas.openxmlformats.org/officeDocument/2006/relationships" xmlns:p="http://schemas.openxmlformats.org/presentationml/2006/main">
+  <p:cSld>
+    <p:spTree>
+      <p:nvGrpSpPr>
+        <p:cNvPr id="1" name=""/>
+        <p:cNvGrpSpPr/>
+        <p:nvPr/>
+      </p:nvGrpSpPr>
+      <p:grpSpPr>
+        <a:xfrm>
+          <a:off x="0" y="0"/>
+          <a:ext cx="0" cy="0"/>
+          <a:chOff x="0" y="0"/>
+          <a:chExt cx="0" cy="0"/>
+        </a:xfrm>
+      </p:grpSpPr>
+      <p:sp>
+        <p:nvSpPr>
+          <p:cNvPr id="2" name="Title 1">
+            <a:extLst>
+              <a:ext uri="{FF2B5EF4-FFF2-40B4-BE49-F238E27FC236}">
+                <a16:creationId xmlns:a16="http://schemas.microsoft.com/office/drawing/2014/main" id="{73C8BF9C-AF28-35C5-4296-A31EBD8E60CD}"/>
+              </a:ext>
+            </a:extLst>
+          </p:cNvPr>
+          <p:cNvSpPr>
+            <a:spLocks noGrp="1"/>
+          </p:cNvSpPr>
+          <p:nvPr>
+            <p:ph type="title"/>
+          </p:nvPr>
+        </p:nvSpPr>
+        <p:spPr/>
+        <p:txBody>
+          <a:bodyPr/>
+          <a:lstStyle/>
+          <a:p>
+            <a:r>
+              <a:rPr lang="en-US" dirty="0"/>
+              <a:t>Adaptive </a:t>
+            </a:r>
+            <a:r>
+              <a:rPr lang="en-US" dirty="0" err="1"/>
+              <a:t>kNN</a:t>
+            </a:r>
+            <a:r>
+              <a:rPr lang="en-US" dirty="0"/>
+              <a:t> for reduced corner-edge pair influence</a:t>
+            </a:r>
+          </a:p>
+        </p:txBody>
+      </p:sp>
+      <p:sp>
+        <p:nvSpPr>
+          <p:cNvPr id="3" name="Content Placeholder 2">
+            <a:extLst>
+              <a:ext uri="{FF2B5EF4-FFF2-40B4-BE49-F238E27FC236}">
+                <a16:creationId xmlns:a16="http://schemas.microsoft.com/office/drawing/2014/main" id="{A00616BD-AFEA-51C2-E003-9F8F163E1970}"/>
+              </a:ext>
+            </a:extLst>
+          </p:cNvPr>
+          <p:cNvSpPr>
+            <a:spLocks noGrp="1"/>
+          </p:cNvSpPr>
+          <p:nvPr>
+            <p:ph idx="1"/>
+          </p:nvPr>
+        </p:nvSpPr>
+        <p:spPr/>
+        <p:txBody>
+          <a:bodyPr/>
+          <a:lstStyle/>
+          <a:p>
+            <a:endParaRPr lang="en-US" dirty="0"/>
+          </a:p>
+        </p:txBody>
+      </p:sp>
+      <p:sp>
+        <p:nvSpPr>
+          <p:cNvPr id="4" name="Picture Placeholder 3">
+            <a:extLst>
+              <a:ext uri="{FF2B5EF4-FFF2-40B4-BE49-F238E27FC236}">
+                <a16:creationId xmlns:a16="http://schemas.microsoft.com/office/drawing/2014/main" id="{F1B0247E-BF4F-914E-A199-205A079C003B}"/>
+              </a:ext>
+            </a:extLst>
+          </p:cNvPr>
+          <p:cNvSpPr>
+            <a:spLocks noGrp="1"/>
+          </p:cNvSpPr>
+          <p:nvPr>
+            <p:ph type="pic" sz="quarter" idx="13"/>
+          </p:nvPr>
+        </p:nvSpPr>
+        <p:spPr/>
+        <p:txBody>
+          <a:bodyPr/>
+          <a:lstStyle/>
+          <a:p>
+            <a:pPr marL="171450" indent="-171450" algn="l">
+              <a:buFont typeface="Arial" panose="020B0604020202020204" pitchFamily="34" charset="0"/>
+              <a:buChar char="•"/>
+            </a:pPr>
+            <a:endParaRPr lang="en-US" dirty="0"/>
+          </a:p>
+        </p:txBody>
+      </p:sp>
+      <p:sp>
+        <p:nvSpPr>
+          <p:cNvPr id="5" name="Picture Placeholder 4">
+            <a:extLst>
+              <a:ext uri="{FF2B5EF4-FFF2-40B4-BE49-F238E27FC236}">
+                <a16:creationId xmlns:a16="http://schemas.microsoft.com/office/drawing/2014/main" id="{C50ED98A-2745-57DC-1B1A-1697A019F6C5}"/>
+              </a:ext>
+            </a:extLst>
+          </p:cNvPr>
+          <p:cNvSpPr>
+            <a:spLocks noGrp="1"/>
+          </p:cNvSpPr>
+          <p:nvPr>
+            <p:ph type="pic" sz="quarter" idx="14"/>
+          </p:nvPr>
+        </p:nvSpPr>
+        <p:spPr/>
+        <p:txBody>
+          <a:bodyPr/>
+          <a:lstStyle/>
+          <a:p>
+            <a:endParaRPr lang="en-US"/>
+          </a:p>
+        </p:txBody>
+      </p:sp>
+      <p:sp>
+        <p:nvSpPr>
+          <p:cNvPr id="6" name="Footer Placeholder 5">
+            <a:extLst>
+              <a:ext uri="{FF2B5EF4-FFF2-40B4-BE49-F238E27FC236}">
+                <a16:creationId xmlns:a16="http://schemas.microsoft.com/office/drawing/2014/main" id="{FB2ACDD2-10FE-2183-51A8-DB43B1FE0035}"/>
+              </a:ext>
+            </a:extLst>
+          </p:cNvPr>
+          <p:cNvSpPr>
+            <a:spLocks noGrp="1"/>
+          </p:cNvSpPr>
+          <p:nvPr>
+            <p:ph type="ftr" sz="quarter" idx="15"/>
+          </p:nvPr>
+        </p:nvSpPr>
+        <p:spPr/>
+        <p:txBody>
+          <a:bodyPr/>
+          <a:lstStyle/>
+          <a:p>
+            <a:r>
+              <a:rPr lang="en-GB"/>
+              <a:t>Title</a:t>
+            </a:r>
+            <a:endParaRPr lang="en-GB" dirty="0"/>
+          </a:p>
+        </p:txBody>
+      </p:sp>
+      <p:sp>
+        <p:nvSpPr>
+          <p:cNvPr id="7" name="Slide Number Placeholder 6">
+            <a:extLst>
+              <a:ext uri="{FF2B5EF4-FFF2-40B4-BE49-F238E27FC236}">
+                <a16:creationId xmlns:a16="http://schemas.microsoft.com/office/drawing/2014/main" id="{34708970-D1AB-D116-C600-75A4487E7A3C}"/>
+              </a:ext>
+            </a:extLst>
+          </p:cNvPr>
+          <p:cNvSpPr>
+            <a:spLocks noGrp="1"/>
+          </p:cNvSpPr>
+          <p:nvPr>
+            <p:ph type="sldNum" sz="quarter" idx="16"/>
+          </p:nvPr>
+        </p:nvSpPr>
+        <p:spPr/>
+        <p:txBody>
+          <a:bodyPr/>
+          <a:lstStyle/>
+          <a:p>
+            <a:fld id="{103EA872-A674-449B-A120-B97244F8E91D}" type="slidenum">
+              <a:rPr lang="en-GB" smtClean="0"/>
+              <a:pPr/>
+              <a:t>10</a:t>
+            </a:fld>
+            <a:endParaRPr lang="en-GB" dirty="0"/>
+          </a:p>
+        </p:txBody>
+      </p:sp>
+      <p:sp>
+        <p:nvSpPr>
+          <p:cNvPr id="8" name="Date Placeholder 7">
+            <a:extLst>
+              <a:ext uri="{FF2B5EF4-FFF2-40B4-BE49-F238E27FC236}">
+                <a16:creationId xmlns:a16="http://schemas.microsoft.com/office/drawing/2014/main" id="{1A21B963-7E9A-74CB-41AB-D0E4FC6EAFFC}"/>
+              </a:ext>
+            </a:extLst>
+          </p:cNvPr>
+          <p:cNvSpPr>
+            <a:spLocks noGrp="1"/>
+          </p:cNvSpPr>
+          <p:nvPr>
+            <p:ph type="dt" sz="half" idx="17"/>
+          </p:nvPr>
+        </p:nvSpPr>
+        <p:spPr/>
+        <p:txBody>
+          <a:bodyPr/>
+          <a:lstStyle/>
+          <a:p>
+            <a:r>
+              <a:rPr lang="da-DK"/>
+              <a:t>Date</a:t>
+            </a:r>
+            <a:endParaRPr lang="en-GB"/>
+          </a:p>
+        </p:txBody>
+      </p:sp>
+    </p:spTree>
+    <p:extLst>
+      <p:ext uri="{BB962C8B-B14F-4D97-AF65-F5344CB8AC3E}">
+        <p14:creationId xmlns:p14="http://schemas.microsoft.com/office/powerpoint/2010/main" val="3528787775"/>
+      </p:ext>
+    </p:extLst>
+  </p:cSld>
+  <p:clrMapOvr>
+    <a:masterClrMapping/>
+  </p:clrMapOvr>
+</p:sld>
+</file>
+
 <file path=ppt/slides/slide2.xml><?xml version="1.0" encoding="utf-8"?>
 <p:sld xmlns:a="http://schemas.openxmlformats.org/drawingml/2006/main" xmlns:r="http://schemas.openxmlformats.org/officeDocument/2006/relationships" xmlns:p="http://schemas.openxmlformats.org/presentationml/2006/main">
   <p:cSld>
@@ -10138,7 +10373,12 @@
             <p:ph type="title"/>
           </p:nvPr>
         </p:nvSpPr>
-        <p:spPr/>
+        <p:spPr>
+          <a:xfrm>
+            <a:off x="118542" y="1340768"/>
+            <a:ext cx="3888432" cy="972716"/>
+          </a:xfrm>
+        </p:spPr>
         <p:txBody>
           <a:bodyPr/>
           <a:lstStyle/>
@@ -10750,7 +10990,7 @@
           <a:bodyPr/>
           <a:lstStyle/>
           <a:p>
-            <a:endParaRPr lang="en-US"/>
+            <a:endParaRPr lang="en-US" dirty="0"/>
           </a:p>
         </p:txBody>
       </p:sp>
@@ -10782,8 +11022,8 @@
         </p:blipFill>
         <p:spPr>
           <a:xfrm>
-            <a:off x="1774825" y="2523565"/>
-            <a:ext cx="4410075" cy="2912596"/>
+            <a:off x="478582" y="1972247"/>
+            <a:ext cx="5562302" cy="3673574"/>
           </a:xfrm>
           <a:prstGeom prst="rect">
             <a:avLst/>
@@ -10977,7 +11217,7 @@
           <p:cNvPr id="11" name="Title 10">
             <a:extLst>
               <a:ext uri="{FF2B5EF4-FFF2-40B4-BE49-F238E27FC236}">
-                <a16:creationId xmlns:a16="http://schemas.microsoft.com/office/drawing/2014/main" id="{B283DB52-7FD6-CEB8-9DF4-36670B97DCD2}"/>
+                <a16:creationId xmlns:a16="http://schemas.microsoft.com/office/drawing/2014/main" id="{0C5F2135-E886-726D-37A2-5569EBDC2F89}"/>
               </a:ext>
             </a:extLst>
           </p:cNvPr>
@@ -10993,174 +11233,6 @@
           <a:bodyPr/>
           <a:lstStyle/>
           <a:p>
-            <a:endParaRPr lang="en-US"/>
-          </a:p>
-        </p:txBody>
-      </p:sp>
-      <p:sp>
-        <p:nvSpPr>
-          <p:cNvPr id="5" name="Footer Placeholder 4">
-            <a:extLst>
-              <a:ext uri="{FF2B5EF4-FFF2-40B4-BE49-F238E27FC236}">
-                <a16:creationId xmlns:a16="http://schemas.microsoft.com/office/drawing/2014/main" id="{3295D47F-1583-D4B5-21BF-33FDABA538A7}"/>
-              </a:ext>
-            </a:extLst>
-          </p:cNvPr>
-          <p:cNvSpPr>
-            <a:spLocks noGrp="1"/>
-          </p:cNvSpPr>
-          <p:nvPr>
-            <p:ph type="ftr" sz="quarter" idx="10"/>
-          </p:nvPr>
-        </p:nvSpPr>
-        <p:spPr/>
-        <p:txBody>
-          <a:bodyPr/>
-          <a:lstStyle/>
-          <a:p>
-            <a:r>
-              <a:rPr lang="en-GB"/>
-              <a:t>Title</a:t>
-            </a:r>
-            <a:endParaRPr lang="en-GB" dirty="0"/>
-          </a:p>
-        </p:txBody>
-      </p:sp>
-      <p:sp>
-        <p:nvSpPr>
-          <p:cNvPr id="6" name="Slide Number Placeholder 5">
-            <a:extLst>
-              <a:ext uri="{FF2B5EF4-FFF2-40B4-BE49-F238E27FC236}">
-                <a16:creationId xmlns:a16="http://schemas.microsoft.com/office/drawing/2014/main" id="{0AD0680E-3754-1BA9-8B17-A4BF3885955E}"/>
-              </a:ext>
-            </a:extLst>
-          </p:cNvPr>
-          <p:cNvSpPr>
-            <a:spLocks noGrp="1"/>
-          </p:cNvSpPr>
-          <p:nvPr>
-            <p:ph type="sldNum" sz="quarter" idx="11"/>
-          </p:nvPr>
-        </p:nvSpPr>
-        <p:spPr/>
-        <p:txBody>
-          <a:bodyPr/>
-          <a:lstStyle/>
-          <a:p>
-            <a:fld id="{103EA872-A674-449B-A120-B97244F8E91D}" type="slidenum">
-              <a:rPr lang="en-GB" smtClean="0"/>
-              <a:pPr/>
-              <a:t>8</a:t>
-            </a:fld>
-            <a:endParaRPr lang="en-GB" dirty="0"/>
-          </a:p>
-        </p:txBody>
-      </p:sp>
-      <p:sp>
-        <p:nvSpPr>
-          <p:cNvPr id="7" name="Date Placeholder 6">
-            <a:extLst>
-              <a:ext uri="{FF2B5EF4-FFF2-40B4-BE49-F238E27FC236}">
-                <a16:creationId xmlns:a16="http://schemas.microsoft.com/office/drawing/2014/main" id="{822DAD08-00E0-9BC1-8213-E7AE6F82D8EA}"/>
-              </a:ext>
-            </a:extLst>
-          </p:cNvPr>
-          <p:cNvSpPr>
-            <a:spLocks noGrp="1"/>
-          </p:cNvSpPr>
-          <p:nvPr>
-            <p:ph type="dt" sz="half" idx="12"/>
-          </p:nvPr>
-        </p:nvSpPr>
-        <p:spPr/>
-        <p:txBody>
-          <a:bodyPr/>
-          <a:lstStyle/>
-          <a:p>
-            <a:r>
-              <a:rPr lang="da-DK"/>
-              <a:t>Date</a:t>
-            </a:r>
-            <a:endParaRPr lang="en-GB"/>
-          </a:p>
-        </p:txBody>
-      </p:sp>
-      <p:sp>
-        <p:nvSpPr>
-          <p:cNvPr id="12" name="Content Placeholder 11">
-            <a:extLst>
-              <a:ext uri="{FF2B5EF4-FFF2-40B4-BE49-F238E27FC236}">
-                <a16:creationId xmlns:a16="http://schemas.microsoft.com/office/drawing/2014/main" id="{938A6508-71C2-1000-3F96-410CE3E9CD2C}"/>
-              </a:ext>
-            </a:extLst>
-          </p:cNvPr>
-          <p:cNvSpPr>
-            <a:spLocks noGrp="1"/>
-          </p:cNvSpPr>
-          <p:nvPr>
-            <p:ph idx="1"/>
-          </p:nvPr>
-        </p:nvSpPr>
-        <p:spPr/>
-        <p:txBody>
-          <a:bodyPr/>
-          <a:lstStyle/>
-          <a:p>
-            <a:endParaRPr lang="en-US"/>
-          </a:p>
-        </p:txBody>
-      </p:sp>
-    </p:spTree>
-    <p:extLst>
-      <p:ext uri="{BB962C8B-B14F-4D97-AF65-F5344CB8AC3E}">
-        <p14:creationId xmlns:p14="http://schemas.microsoft.com/office/powerpoint/2010/main" val="3441030184"/>
-      </p:ext>
-    </p:extLst>
-  </p:cSld>
-  <p:clrMapOvr>
-    <a:masterClrMapping/>
-  </p:clrMapOvr>
-</p:sld>
-</file>
-
-<file path=ppt/slides/slide9.xml><?xml version="1.0" encoding="utf-8"?>
-<p:sld xmlns:a="http://schemas.openxmlformats.org/drawingml/2006/main" xmlns:r="http://schemas.openxmlformats.org/officeDocument/2006/relationships" xmlns:p="http://schemas.openxmlformats.org/presentationml/2006/main">
-  <p:cSld>
-    <p:spTree>
-      <p:nvGrpSpPr>
-        <p:cNvPr id="1" name=""/>
-        <p:cNvGrpSpPr/>
-        <p:nvPr/>
-      </p:nvGrpSpPr>
-      <p:grpSpPr>
-        <a:xfrm>
-          <a:off x="0" y="0"/>
-          <a:ext cx="0" cy="0"/>
-          <a:chOff x="0" y="0"/>
-          <a:chExt cx="0" cy="0"/>
-        </a:xfrm>
-      </p:grpSpPr>
-      <p:sp>
-        <p:nvSpPr>
-          <p:cNvPr id="11" name="Title 10">
-            <a:extLst>
-              <a:ext uri="{FF2B5EF4-FFF2-40B4-BE49-F238E27FC236}">
-                <a16:creationId xmlns:a16="http://schemas.microsoft.com/office/drawing/2014/main" id="{0C5F2135-E886-726D-37A2-5569EBDC2F89}"/>
-              </a:ext>
-            </a:extLst>
-          </p:cNvPr>
-          <p:cNvSpPr>
-            <a:spLocks noGrp="1"/>
-          </p:cNvSpPr>
-          <p:nvPr>
-            <p:ph type="title"/>
-          </p:nvPr>
-        </p:nvSpPr>
-        <p:spPr/>
-        <p:txBody>
-          <a:bodyPr/>
-          <a:lstStyle/>
-          <a:p>
             <a:r>
               <a:rPr lang="en-US" dirty="0"/>
               <a:t>Naïve extrapolate:</a:t>
@@ -11228,7 +11300,7 @@
             <a:fld id="{103EA872-A674-449B-A120-B97244F8E91D}" type="slidenum">
               <a:rPr lang="en-GB" smtClean="0"/>
               <a:pPr/>
-              <a:t>9</a:t>
+              <a:t>8</a:t>
             </a:fld>
             <a:endParaRPr lang="en-GB" dirty="0"/>
           </a:p>
@@ -11288,7 +11360,7 @@
         </p:blipFill>
         <p:spPr bwMode="auto">
           <a:xfrm>
-            <a:off x="8331200" y="3429000"/>
+            <a:off x="8117049" y="3508935"/>
             <a:ext cx="3859213" cy="2880320"/>
           </a:xfrm>
           <a:prstGeom prst="rect">
@@ -11966,6 +12038,440 @@
     <p:extLst>
       <p:ext uri="{BB962C8B-B14F-4D97-AF65-F5344CB8AC3E}">
         <p14:creationId xmlns:p14="http://schemas.microsoft.com/office/powerpoint/2010/main" val="2469966279"/>
+      </p:ext>
+    </p:extLst>
+  </p:cSld>
+  <p:clrMapOvr>
+    <a:masterClrMapping/>
+  </p:clrMapOvr>
+</p:sld>
+</file>
+
+<file path=ppt/slides/slide9.xml><?xml version="1.0" encoding="utf-8"?>
+<p:sld xmlns:a="http://schemas.openxmlformats.org/drawingml/2006/main" xmlns:r="http://schemas.openxmlformats.org/officeDocument/2006/relationships" xmlns:p="http://schemas.openxmlformats.org/presentationml/2006/main">
+  <p:cSld>
+    <p:spTree>
+      <p:nvGrpSpPr>
+        <p:cNvPr id="1" name="">
+          <a:extLst>
+            <a:ext uri="{FF2B5EF4-FFF2-40B4-BE49-F238E27FC236}">
+              <a16:creationId xmlns:a16="http://schemas.microsoft.com/office/drawing/2014/main" id="{9DD1267F-7F05-55CD-3973-B6AE9746CB22}"/>
+            </a:ext>
+          </a:extLst>
+        </p:cNvPr>
+        <p:cNvGrpSpPr/>
+        <p:nvPr/>
+      </p:nvGrpSpPr>
+      <p:grpSpPr>
+        <a:xfrm>
+          <a:off x="0" y="0"/>
+          <a:ext cx="0" cy="0"/>
+          <a:chOff x="0" y="0"/>
+          <a:chExt cx="0" cy="0"/>
+        </a:xfrm>
+      </p:grpSpPr>
+      <p:sp>
+        <p:nvSpPr>
+          <p:cNvPr id="11" name="Title 10">
+            <a:extLst>
+              <a:ext uri="{FF2B5EF4-FFF2-40B4-BE49-F238E27FC236}">
+                <a16:creationId xmlns:a16="http://schemas.microsoft.com/office/drawing/2014/main" id="{E9534E6E-7932-25B6-FD58-075CDB88EC2C}"/>
+              </a:ext>
+            </a:extLst>
+          </p:cNvPr>
+          <p:cNvSpPr>
+            <a:spLocks noGrp="1"/>
+          </p:cNvSpPr>
+          <p:nvPr>
+            <p:ph type="title"/>
+          </p:nvPr>
+        </p:nvSpPr>
+        <p:spPr/>
+        <p:txBody>
+          <a:bodyPr/>
+          <a:lstStyle/>
+          <a:p>
+            <a:r>
+              <a:rPr lang="en-US" dirty="0"/>
+              <a:t>Naïve extrapolate:</a:t>
+            </a:r>
+            <a:br>
+              <a:rPr lang="en-US" dirty="0"/>
+            </a:br>
+            <a:r>
+              <a:rPr lang="en-US" dirty="0"/>
+              <a:t>k-NN</a:t>
+            </a:r>
+          </a:p>
+        </p:txBody>
+      </p:sp>
+      <p:sp>
+        <p:nvSpPr>
+          <p:cNvPr id="4" name="Footer Placeholder 3">
+            <a:extLst>
+              <a:ext uri="{FF2B5EF4-FFF2-40B4-BE49-F238E27FC236}">
+                <a16:creationId xmlns:a16="http://schemas.microsoft.com/office/drawing/2014/main" id="{0B3BFAA2-51AD-DEC5-4F54-9402419651B7}"/>
+              </a:ext>
+            </a:extLst>
+          </p:cNvPr>
+          <p:cNvSpPr>
+            <a:spLocks noGrp="1"/>
+          </p:cNvSpPr>
+          <p:nvPr>
+            <p:ph type="ftr" sz="quarter" idx="15"/>
+          </p:nvPr>
+        </p:nvSpPr>
+        <p:spPr/>
+        <p:txBody>
+          <a:bodyPr/>
+          <a:lstStyle/>
+          <a:p>
+            <a:r>
+              <a:rPr lang="en-GB"/>
+              <a:t>Title</a:t>
+            </a:r>
+            <a:endParaRPr lang="en-GB" dirty="0"/>
+          </a:p>
+        </p:txBody>
+      </p:sp>
+      <p:sp>
+        <p:nvSpPr>
+          <p:cNvPr id="5" name="Slide Number Placeholder 4">
+            <a:extLst>
+              <a:ext uri="{FF2B5EF4-FFF2-40B4-BE49-F238E27FC236}">
+                <a16:creationId xmlns:a16="http://schemas.microsoft.com/office/drawing/2014/main" id="{31196CC9-F33E-3BE2-E5B7-265D3A50001B}"/>
+              </a:ext>
+            </a:extLst>
+          </p:cNvPr>
+          <p:cNvSpPr>
+            <a:spLocks noGrp="1"/>
+          </p:cNvSpPr>
+          <p:nvPr>
+            <p:ph type="sldNum" sz="quarter" idx="16"/>
+          </p:nvPr>
+        </p:nvSpPr>
+        <p:spPr/>
+        <p:txBody>
+          <a:bodyPr/>
+          <a:lstStyle/>
+          <a:p>
+            <a:fld id="{103EA872-A674-449B-A120-B97244F8E91D}" type="slidenum">
+              <a:rPr lang="en-GB" smtClean="0"/>
+              <a:pPr/>
+              <a:t>9</a:t>
+            </a:fld>
+            <a:endParaRPr lang="en-GB" dirty="0"/>
+          </a:p>
+        </p:txBody>
+      </p:sp>
+      <p:sp>
+        <p:nvSpPr>
+          <p:cNvPr id="6" name="Date Placeholder 5">
+            <a:extLst>
+              <a:ext uri="{FF2B5EF4-FFF2-40B4-BE49-F238E27FC236}">
+                <a16:creationId xmlns:a16="http://schemas.microsoft.com/office/drawing/2014/main" id="{10A01872-B7B7-912F-5E3E-8816084AD6A6}"/>
+              </a:ext>
+            </a:extLst>
+          </p:cNvPr>
+          <p:cNvSpPr>
+            <a:spLocks noGrp="1"/>
+          </p:cNvSpPr>
+          <p:nvPr>
+            <p:ph type="dt" sz="half" idx="17"/>
+          </p:nvPr>
+        </p:nvSpPr>
+        <p:spPr/>
+        <p:txBody>
+          <a:bodyPr/>
+          <a:lstStyle/>
+          <a:p>
+            <a:r>
+              <a:rPr lang="da-DK"/>
+              <a:t>Date</a:t>
+            </a:r>
+            <a:endParaRPr lang="en-GB"/>
+          </a:p>
+        </p:txBody>
+      </p:sp>
+      <p:pic>
+        <p:nvPicPr>
+          <p:cNvPr id="19" name="Content Placeholder 12">
+            <a:extLst>
+              <a:ext uri="{FF2B5EF4-FFF2-40B4-BE49-F238E27FC236}">
+                <a16:creationId xmlns:a16="http://schemas.microsoft.com/office/drawing/2014/main" id="{900C229F-6939-622D-FE96-2482D7C0DB35}"/>
+              </a:ext>
+            </a:extLst>
+          </p:cNvPr>
+          <p:cNvPicPr>
+            <a:picLocks noGrp="1" noChangeAspect="1"/>
+          </p:cNvPicPr>
+          <p:nvPr>
+            <p:ph idx="1"/>
+          </p:nvPr>
+        </p:nvPicPr>
+        <p:blipFill>
+          <a:blip r:embed="rId2">
+            <a:extLst>
+              <a:ext uri="{28A0092B-C50C-407E-A947-70E740481C1C}">
+                <a14:useLocalDpi xmlns:a14="http://schemas.microsoft.com/office/drawing/2010/main" val="0"/>
+              </a:ext>
+            </a:extLst>
+          </a:blip>
+          <a:srcRect l="2487" r="2487"/>
+          <a:stretch/>
+        </p:blipFill>
+        <p:spPr bwMode="auto">
+          <a:xfrm>
+            <a:off x="622599" y="2132856"/>
+            <a:ext cx="6048375" cy="3928617"/>
+          </a:xfrm>
+          <a:prstGeom prst="rect">
+            <a:avLst/>
+          </a:prstGeom>
+          <a:noFill/>
+          <a:ln>
+            <a:noFill/>
+          </a:ln>
+          <a:extLst>
+            <a:ext uri="{909E8E84-426E-40DD-AFC4-6F175D3DCCD1}">
+              <a14:hiddenFill xmlns:a14="http://schemas.microsoft.com/office/drawing/2010/main">
+                <a:solidFill>
+                  <a:schemeClr val="accent1"/>
+                </a:solidFill>
+              </a14:hiddenFill>
+            </a:ext>
+            <a:ext uri="{91240B29-F687-4F45-9708-019B960494DF}">
+              <a14:hiddenLine xmlns:a14="http://schemas.microsoft.com/office/drawing/2010/main" w="9525">
+                <a:solidFill>
+                  <a:schemeClr val="tx1"/>
+                </a:solidFill>
+                <a:miter lim="800000"/>
+                <a:headEnd/>
+                <a:tailEnd/>
+              </a14:hiddenLine>
+            </a:ext>
+          </a:extLst>
+        </p:spPr>
+      </p:pic>
+      <p:sp>
+        <p:nvSpPr>
+          <p:cNvPr id="2" name="Picture Placeholder 1">
+            <a:extLst>
+              <a:ext uri="{FF2B5EF4-FFF2-40B4-BE49-F238E27FC236}">
+                <a16:creationId xmlns:a16="http://schemas.microsoft.com/office/drawing/2014/main" id="{9F6D4079-49C8-F8F3-924A-CD1DBEA66A80}"/>
+              </a:ext>
+            </a:extLst>
+          </p:cNvPr>
+          <p:cNvSpPr>
+            <a:spLocks noGrp="1"/>
+          </p:cNvSpPr>
+          <p:nvPr>
+            <p:ph type="pic" sz="quarter" idx="13"/>
+          </p:nvPr>
+        </p:nvSpPr>
+        <p:spPr/>
+        <p:txBody>
+          <a:bodyPr/>
+          <a:lstStyle/>
+          <a:p>
+            <a:pPr algn="l"/>
+            <a:r>
+              <a:rPr lang="en-US" dirty="0"/>
+              <a:t>Pit-falls:</a:t>
+            </a:r>
+            <a:endParaRPr lang="en-US" dirty="0">
+              <a:sym typeface="Wingdings" panose="05000000000000000000" pitchFamily="2" charset="2"/>
+            </a:endParaRPr>
+          </a:p>
+          <a:p>
+            <a:pPr marL="171450" indent="-171450" algn="l">
+              <a:buFont typeface="Arial" panose="020B0604020202020204" pitchFamily="34" charset="0"/>
+              <a:buChar char="•"/>
+            </a:pPr>
+            <a:r>
+              <a:rPr lang="en-US" dirty="0"/>
+              <a:t>Number of equivalent pairs scale (sort of) linearly </a:t>
+            </a:r>
+            <a:r>
+              <a:rPr lang="en-US" dirty="0">
+                <a:sym typeface="Wingdings" panose="05000000000000000000" pitchFamily="2" charset="2"/>
+              </a:rPr>
+              <a:t> overweight of corner-neighboring pairs</a:t>
+            </a:r>
+          </a:p>
+          <a:p>
+            <a:pPr marL="171450" indent="-171450" algn="l">
+              <a:buFont typeface="Arial" panose="020B0604020202020204" pitchFamily="34" charset="0"/>
+              <a:buChar char="•"/>
+            </a:pPr>
+            <a:endParaRPr lang="en-US" dirty="0">
+              <a:sym typeface="Wingdings" panose="05000000000000000000" pitchFamily="2" charset="2"/>
+            </a:endParaRPr>
+          </a:p>
+          <a:p>
+            <a:pPr marL="171450" indent="-171450" algn="l">
+              <a:buFont typeface="Arial" panose="020B0604020202020204" pitchFamily="34" charset="0"/>
+              <a:buChar char="•"/>
+            </a:pPr>
+            <a:r>
+              <a:rPr lang="en-US" dirty="0"/>
+              <a:t>4-atom corners occupy more space </a:t>
+            </a:r>
+            <a:r>
+              <a:rPr lang="en-US" dirty="0">
+                <a:sym typeface="Wingdings" panose="05000000000000000000" pitchFamily="2" charset="2"/>
+              </a:rPr>
+              <a:t> more edge pairs for this region</a:t>
+            </a:r>
+          </a:p>
+          <a:p>
+            <a:pPr marL="171450" indent="-171450" algn="l">
+              <a:buFont typeface="Arial" panose="020B0604020202020204" pitchFamily="34" charset="0"/>
+              <a:buChar char="•"/>
+            </a:pPr>
+            <a:endParaRPr lang="en-US" dirty="0">
+              <a:sym typeface="Wingdings" panose="05000000000000000000" pitchFamily="2" charset="2"/>
+            </a:endParaRPr>
+          </a:p>
+          <a:p>
+            <a:pPr marL="171450" indent="-171450" algn="l">
+              <a:buFont typeface="Arial" panose="020B0604020202020204" pitchFamily="34" charset="0"/>
+              <a:buChar char="•"/>
+            </a:pPr>
+            <a:endParaRPr lang="en-US" dirty="0">
+              <a:sym typeface="Wingdings" panose="05000000000000000000" pitchFamily="2" charset="2"/>
+            </a:endParaRPr>
+          </a:p>
+          <a:p>
+            <a:pPr marL="171450" indent="-171450" algn="l">
+              <a:buFont typeface="Arial" panose="020B0604020202020204" pitchFamily="34" charset="0"/>
+              <a:buChar char="•"/>
+            </a:pPr>
+            <a:endParaRPr lang="en-US" dirty="0"/>
+          </a:p>
+        </p:txBody>
+      </p:sp>
+      <p:sp>
+        <p:nvSpPr>
+          <p:cNvPr id="3" name="Picture Placeholder 2">
+            <a:extLst>
+              <a:ext uri="{FF2B5EF4-FFF2-40B4-BE49-F238E27FC236}">
+                <a16:creationId xmlns:a16="http://schemas.microsoft.com/office/drawing/2014/main" id="{4E1C88CD-2282-306D-8B1E-9E7A1F007938}"/>
+              </a:ext>
+            </a:extLst>
+          </p:cNvPr>
+          <p:cNvSpPr>
+            <a:spLocks noGrp="1"/>
+          </p:cNvSpPr>
+          <p:nvPr>
+            <p:ph type="pic" sz="quarter" idx="14"/>
+          </p:nvPr>
+        </p:nvSpPr>
+        <p:spPr/>
+        <p:txBody>
+          <a:bodyPr/>
+          <a:lstStyle/>
+          <a:p>
+            <a:endParaRPr lang="en-US"/>
+          </a:p>
+        </p:txBody>
+      </p:sp>
+      <p:cxnSp>
+        <p:nvCxnSpPr>
+          <p:cNvPr id="8" name="Straight Arrow Connector 7">
+            <a:extLst>
+              <a:ext uri="{FF2B5EF4-FFF2-40B4-BE49-F238E27FC236}">
+                <a16:creationId xmlns:a16="http://schemas.microsoft.com/office/drawing/2014/main" id="{19D76F0D-37E2-8AF3-6BD7-12F94DFE5C40}"/>
+              </a:ext>
+            </a:extLst>
+          </p:cNvPr>
+          <p:cNvCxnSpPr/>
+          <p:nvPr/>
+        </p:nvCxnSpPr>
+        <p:spPr bwMode="auto">
+          <a:xfrm>
+            <a:off x="1355240" y="4221088"/>
+            <a:ext cx="1427598" cy="792088"/>
+          </a:xfrm>
+          <a:prstGeom prst="straightConnector1">
+            <a:avLst/>
+          </a:prstGeom>
+          <a:solidFill>
+            <a:schemeClr val="accent1"/>
+          </a:solidFill>
+          <a:ln w="9525" cap="flat" cmpd="sng" algn="ctr">
+            <a:solidFill>
+              <a:schemeClr val="tx1"/>
+            </a:solidFill>
+            <a:prstDash val="solid"/>
+            <a:miter lim="800000"/>
+            <a:headEnd type="none" w="med" len="med"/>
+            <a:tailEnd type="triangle"/>
+          </a:ln>
+          <a:effectLst/>
+          <a:extLst>
+            <a:ext uri="{AF507438-7753-43E0-B8FC-AC1667EBCBE1}">
+              <a14:hiddenEffects xmlns:a14="http://schemas.microsoft.com/office/drawing/2010/main">
+                <a:effectLst>
+                  <a:outerShdw dist="35921" dir="2700000" algn="ctr" rotWithShape="0">
+                    <a:schemeClr val="bg2"/>
+                  </a:outerShdw>
+                </a:effectLst>
+              </a14:hiddenEffects>
+            </a:ext>
+          </a:extLst>
+        </p:spPr>
+      </p:cxnSp>
+      <p:cxnSp>
+        <p:nvCxnSpPr>
+          <p:cNvPr id="10" name="Straight Arrow Connector 9">
+            <a:extLst>
+              <a:ext uri="{FF2B5EF4-FFF2-40B4-BE49-F238E27FC236}">
+                <a16:creationId xmlns:a16="http://schemas.microsoft.com/office/drawing/2014/main" id="{51B7DA9E-4E5E-D8AB-4913-A1C7A8D360D4}"/>
+              </a:ext>
+            </a:extLst>
+          </p:cNvPr>
+          <p:cNvCxnSpPr/>
+          <p:nvPr/>
+        </p:nvCxnSpPr>
+        <p:spPr bwMode="auto">
+          <a:xfrm>
+            <a:off x="2864098" y="4190022"/>
+            <a:ext cx="422796" cy="247090"/>
+          </a:xfrm>
+          <a:prstGeom prst="straightConnector1">
+            <a:avLst/>
+          </a:prstGeom>
+          <a:solidFill>
+            <a:schemeClr val="accent1"/>
+          </a:solidFill>
+          <a:ln w="9525" cap="flat" cmpd="sng" algn="ctr">
+            <a:solidFill>
+              <a:schemeClr val="tx1"/>
+            </a:solidFill>
+            <a:prstDash val="solid"/>
+            <a:miter lim="800000"/>
+            <a:headEnd type="none" w="med" len="med"/>
+            <a:tailEnd type="triangle"/>
+          </a:ln>
+          <a:effectLst/>
+          <a:extLst>
+            <a:ext uri="{AF507438-7753-43E0-B8FC-AC1667EBCBE1}">
+              <a14:hiddenEffects xmlns:a14="http://schemas.microsoft.com/office/drawing/2010/main">
+                <a:effectLst>
+                  <a:outerShdw dist="35921" dir="2700000" algn="ctr" rotWithShape="0">
+                    <a:schemeClr val="bg2"/>
+                  </a:outerShdw>
+                </a:effectLst>
+              </a14:hiddenEffects>
+            </a:ext>
+          </a:extLst>
+        </p:spPr>
+      </p:cxnSp>
+    </p:spTree>
+    <p:extLst>
+      <p:ext uri="{BB962C8B-B14F-4D97-AF65-F5344CB8AC3E}">
+        <p14:creationId xmlns:p14="http://schemas.microsoft.com/office/powerpoint/2010/main" val="3865463118"/>
       </p:ext>
     </p:extLst>
   </p:cSld>
@@ -12911,22 +13417,26 @@
 </file>
 
 <file path=customXml/item10.xml><?xml version="1.0" encoding="utf-8"?>
+<TemplafySlideTemplateConfiguration><![CDATA[{"elementsMetadata":[],"documentContentValidatorConfiguration":{"enableDocumentContentValidator":false,"documentContentValidatorVersion":0},"slideId":"636957682264213454","enableDocumentContentUpdater":true,"version":"1.2"}]]></TemplafySlideTemplateConfiguration>
+</file>
+
+<file path=customXml/item11.xml><?xml version="1.0" encoding="utf-8"?>
 <TemplafySlideFormConfiguration><![CDATA[{"formFields":[],"formDataEntries":[]}]]></TemplafySlideFormConfiguration>
 </file>
 
-<file path=customXml/item11.xml><?xml version="1.0" encoding="utf-8"?>
+<file path=customXml/item2.xml><?xml version="1.0" encoding="utf-8"?>
 <TemplafyTemplateConfiguration><![CDATA[{"elementsMetadata":[],"transformationConfigurations":[{"language":"{{DocumentLanguage}}","disableUpdates":false,"type":"proofingLanguage"}],"templateName":"DTU Template 16_9 - Purple","templateDescription":"","enableDocumentContentUpdater":true,"version":"1.2"}]]></TemplafyTemplateConfiguration>
 </file>
 
-<file path=customXml/item2.xml><?xml version="1.0" encoding="utf-8"?>
-<TemplafySlideTemplateConfiguration><![CDATA[{"elementsMetadata":[],"documentContentValidatorConfiguration":{"enableDocumentContentValidator":false,"documentContentValidatorVersion":0},"slideId":"636957682264213454","enableDocumentContentUpdater":true,"version":"1.2"}]]></TemplafySlideTemplateConfiguration>
-</file>
-
 <file path=customXml/item3.xml><?xml version="1.0" encoding="utf-8"?>
-<TemplafySlideTemplateConfiguration><![CDATA[{"elementsMetadata":[],"documentContentValidatorConfiguration":{"enableDocumentContentValidator":false,"documentContentValidatorVersion":0},"slideId":"636957682264370159","enableDocumentContentUpdater":true,"version":"1.2"}]]></TemplafySlideTemplateConfiguration>
+<TemplafyFormConfiguration><![CDATA[{"formFields":[{"required":false,"type":"datePicker","name":"Date","label":"Date","helpTexts":{"prefix":"","postfix":""},"spacing":{},"fullyQualifiedName":"Date"},{"required":false,"placeholder":"","lines":0,"type":"textBox","name":"PresentationTitle","label":"Presentation title","helpTexts":{"prefix":"","postfix":""},"spacing":{},"fullyQualifiedName":"PresentationTitle"}],"formDataEntries":[]}]]></TemplafyFormConfiguration>
 </file>
 
 <file path=customXml/item4.xml><?xml version="1.0" encoding="utf-8"?>
+<TemplafySlideFormConfiguration><![CDATA[{"formFields":[],"formDataEntries":[]}]]></TemplafySlideFormConfiguration>
+</file>
+
+<file path=customXml/item5.xml><?xml version="1.0" encoding="utf-8"?>
 <?mso-contentType ?>
 <FormTemplates xmlns="http://schemas.microsoft.com/sharepoint/v3/contenttype/forms">
   <Display>DocumentLibraryForm</Display>
@@ -12935,25 +13445,7 @@
 </FormTemplates>
 </file>
 
-<file path=customXml/item5.xml><?xml version="1.0" encoding="utf-8"?>
-<TemplafyFormConfiguration><![CDATA[{"formFields":[{"required":false,"type":"datePicker","name":"Date","label":"Date","helpTexts":{"prefix":"","postfix":""},"spacing":{},"fullyQualifiedName":"Date"},{"required":false,"placeholder":"","lines":0,"type":"textBox","name":"PresentationTitle","label":"Presentation title","helpTexts":{"prefix":"","postfix":""},"spacing":{},"fullyQualifiedName":"PresentationTitle"}],"formDataEntries":[]}]]></TemplafyFormConfiguration>
-</file>
-
 <file path=customXml/item6.xml><?xml version="1.0" encoding="utf-8"?>
-<TemplafySlideFormConfiguration><![CDATA[{"formFields":[],"formDataEntries":[]}]]></TemplafySlideFormConfiguration>
-</file>
-
-<file path=customXml/item7.xml><?xml version="1.0" encoding="utf-8"?>
-<p:properties xmlns:p="http://schemas.microsoft.com/office/2006/metadata/properties" xmlns:xsi="http://www.w3.org/2001/XMLSchema-instance" xmlns:pc="http://schemas.microsoft.com/office/infopath/2007/PartnerControls">
-  <documentManagement/>
-</p:properties>
-</file>
-
-<file path=customXml/item8.xml><?xml version="1.0" encoding="utf-8"?>
-<TemplafySlideTemplateConfiguration><![CDATA[{"elementsMetadata":[],"documentContentValidatorConfiguration":{"enableDocumentContentValidator":false,"documentContentValidatorVersion":0},"slideId":"636957682264057965","enableDocumentContentUpdater":true,"version":"1.2"}]]></TemplafySlideTemplateConfiguration>
-</file>
-
-<file path=customXml/item9.xml><?xml version="1.0" encoding="utf-8"?>
 <ct:contentTypeSchema xmlns:ct="http://schemas.microsoft.com/office/2006/metadata/contentType" xmlns:ma="http://schemas.microsoft.com/office/2006/metadata/properties/metaAttributes" ct:_="" ma:_="" ma:contentTypeName="Document" ma:contentTypeID="0x0101009ADA1FD2B40FDA458284BB6FCA763489" ma:contentTypeVersion="5" ma:contentTypeDescription="Create a new document." ma:contentTypeScope="" ma:versionID="72b2569ebc96083092f6d8e76413cd52">
   <xsd:schema xmlns:xsd="http://www.w3.org/2001/XMLSchema" xmlns:xs="http://www.w3.org/2001/XMLSchema" xmlns:p="http://schemas.microsoft.com/office/2006/metadata/properties" xmlns:ns2="683dcda1-f8c3-442f-ae64-e236c052732d" xmlns:ns3="715bde23-c48d-41ea-a697-dffaa8fbae8d" targetNamespace="http://schemas.microsoft.com/office/2006/metadata/properties" ma:root="true" ma:fieldsID="df14c340b530a7b5c38005fefa6a5693" ns2:_="" ns3:_="">
     <xsd:import namespace="683dcda1-f8c3-442f-ae64-e236c052732d"/>
@@ -13124,37 +13616,57 @@
 </ct:contentTypeSchema>
 </file>
 
+<file path=customXml/item7.xml><?xml version="1.0" encoding="utf-8"?>
+<TemplafySlideTemplateConfiguration><![CDATA[{"elementsMetadata":[],"documentContentValidatorConfiguration":{"enableDocumentContentValidator":false,"documentContentValidatorVersion":0},"slideId":"636957682264057965","enableDocumentContentUpdater":true,"version":"1.2"}]]></TemplafySlideTemplateConfiguration>
+</file>
+
+<file path=customXml/item8.xml><?xml version="1.0" encoding="utf-8"?>
+<TemplafySlideTemplateConfiguration><![CDATA[{"elementsMetadata":[],"documentContentValidatorConfiguration":{"enableDocumentContentValidator":false,"documentContentValidatorVersion":0},"slideId":"636957682264370159","enableDocumentContentUpdater":true,"version":"1.2"}]]></TemplafySlideTemplateConfiguration>
+</file>
+
+<file path=customXml/item9.xml><?xml version="1.0" encoding="utf-8"?>
+<p:properties xmlns:p="http://schemas.microsoft.com/office/2006/metadata/properties" xmlns:xsi="http://www.w3.org/2001/XMLSchema-instance" xmlns:pc="http://schemas.microsoft.com/office/infopath/2007/PartnerControls">
+  <documentManagement/>
+</p:properties>
+</file>
+
 <file path=customXml/itemProps1.xml><?xml version="1.0" encoding="utf-8"?>
+<ds:datastoreItem xmlns:ds="http://schemas.openxmlformats.org/officeDocument/2006/customXml" ds:itemID="{A24B75EB-8202-4907-9D1E-5F9CF0C29483}">
+  <ds:schemaRefs/>
+</ds:datastoreItem>
+</file>
+
+<file path=customXml/itemProps10.xml><?xml version="1.0" encoding="utf-8"?>
+<ds:datastoreItem xmlns:ds="http://schemas.openxmlformats.org/officeDocument/2006/customXml" ds:itemID="{B30A78E7-315B-4170-8116-72928D1FEAD9}">
+  <ds:schemaRefs/>
+</ds:datastoreItem>
+</file>
+
+<file path=customXml/itemProps11.xml><?xml version="1.0" encoding="utf-8"?>
 <ds:datastoreItem xmlns:ds="http://schemas.openxmlformats.org/officeDocument/2006/customXml" ds:itemID="{E618FA3B-8A67-40AE-8AE5-229504AB69D3}">
   <ds:schemaRefs/>
 </ds:datastoreItem>
 </file>
 
-<file path=customXml/itemProps10.xml><?xml version="1.0" encoding="utf-8"?>
+<file path=customXml/itemProps2.xml><?xml version="1.0" encoding="utf-8"?>
+<ds:datastoreItem xmlns:ds="http://schemas.openxmlformats.org/officeDocument/2006/customXml" ds:itemID="{1334258C-C3E7-4029-A615-C886A240FB15}">
+  <ds:schemaRefs/>
+</ds:datastoreItem>
+</file>
+
+<file path=customXml/itemProps3.xml><?xml version="1.0" encoding="utf-8"?>
+<ds:datastoreItem xmlns:ds="http://schemas.openxmlformats.org/officeDocument/2006/customXml" ds:itemID="{69ED2CA6-29BB-4407-9012-18ED2ECCD16E}">
+  <ds:schemaRefs/>
+</ds:datastoreItem>
+</file>
+
+<file path=customXml/itemProps4.xml><?xml version="1.0" encoding="utf-8"?>
 <ds:datastoreItem xmlns:ds="http://schemas.openxmlformats.org/officeDocument/2006/customXml" ds:itemID="{403BE795-51D5-47B5-B747-A10BFE22AFA8}">
   <ds:schemaRefs/>
 </ds:datastoreItem>
 </file>
 
-<file path=customXml/itemProps11.xml><?xml version="1.0" encoding="utf-8"?>
-<ds:datastoreItem xmlns:ds="http://schemas.openxmlformats.org/officeDocument/2006/customXml" ds:itemID="{1334258C-C3E7-4029-A615-C886A240FB15}">
-  <ds:schemaRefs/>
-</ds:datastoreItem>
-</file>
-
-<file path=customXml/itemProps2.xml><?xml version="1.0" encoding="utf-8"?>
-<ds:datastoreItem xmlns:ds="http://schemas.openxmlformats.org/officeDocument/2006/customXml" ds:itemID="{B30A78E7-315B-4170-8116-72928D1FEAD9}">
-  <ds:schemaRefs/>
-</ds:datastoreItem>
-</file>
-
-<file path=customXml/itemProps3.xml><?xml version="1.0" encoding="utf-8"?>
-<ds:datastoreItem xmlns:ds="http://schemas.openxmlformats.org/officeDocument/2006/customXml" ds:itemID="{3DB14396-8B0C-45B4-9B8F-11E9F605DE89}">
-  <ds:schemaRefs/>
-</ds:datastoreItem>
-</file>
-
-<file path=customXml/itemProps4.xml><?xml version="1.0" encoding="utf-8"?>
+<file path=customXml/itemProps5.xml><?xml version="1.0" encoding="utf-8"?>
 <ds:datastoreItem xmlns:ds="http://schemas.openxmlformats.org/officeDocument/2006/customXml" ds:itemID="{3FAD9687-A325-465A-822F-98C7D264CFD7}">
   <ds:schemaRefs>
     <ds:schemaRef ds:uri="http://schemas.microsoft.com/sharepoint/v3/contenttype/forms"/>
@@ -13162,34 +13674,7 @@
 </ds:datastoreItem>
 </file>
 
-<file path=customXml/itemProps5.xml><?xml version="1.0" encoding="utf-8"?>
-<ds:datastoreItem xmlns:ds="http://schemas.openxmlformats.org/officeDocument/2006/customXml" ds:itemID="{69ED2CA6-29BB-4407-9012-18ED2ECCD16E}">
-  <ds:schemaRefs/>
-</ds:datastoreItem>
-</file>
-
 <file path=customXml/itemProps6.xml><?xml version="1.0" encoding="utf-8"?>
-<ds:datastoreItem xmlns:ds="http://schemas.openxmlformats.org/officeDocument/2006/customXml" ds:itemID="{A24B75EB-8202-4907-9D1E-5F9CF0C29483}">
-  <ds:schemaRefs/>
-</ds:datastoreItem>
-</file>
-
-<file path=customXml/itemProps7.xml><?xml version="1.0" encoding="utf-8"?>
-<ds:datastoreItem xmlns:ds="http://schemas.openxmlformats.org/officeDocument/2006/customXml" ds:itemID="{C7696DC1-7A22-4198-A4D1-783EAEBC6DD4}">
-  <ds:schemaRefs>
-    <ds:schemaRef ds:uri="http://schemas.microsoft.com/office/2006/metadata/properties"/>
-    <ds:schemaRef ds:uri="http://schemas.microsoft.com/office/infopath/2007/PartnerControls"/>
-  </ds:schemaRefs>
-</ds:datastoreItem>
-</file>
-
-<file path=customXml/itemProps8.xml><?xml version="1.0" encoding="utf-8"?>
-<ds:datastoreItem xmlns:ds="http://schemas.openxmlformats.org/officeDocument/2006/customXml" ds:itemID="{ECA1DA60-FB17-4EB5-97F4-62F99A1A733D}">
-  <ds:schemaRefs/>
-</ds:datastoreItem>
-</file>
-
-<file path=customXml/itemProps9.xml><?xml version="1.0" encoding="utf-8"?>
 <ds:datastoreItem xmlns:ds="http://schemas.openxmlformats.org/officeDocument/2006/customXml" ds:itemID="{9F0C0281-0754-4C07-B1CB-D9771AB751DC}">
   <ds:schemaRefs>
     <ds:schemaRef ds:uri="http://schemas.microsoft.com/office/2006/metadata/contentType"/>
@@ -13206,4 +13691,25 @@
     <ds:schemaRef ds:uri="http://schemas.microsoft.com/internal/obd"/>
   </ds:schemaRefs>
 </ds:datastoreItem>
+</file>
+
+<file path=customXml/itemProps7.xml><?xml version="1.0" encoding="utf-8"?>
+<ds:datastoreItem xmlns:ds="http://schemas.openxmlformats.org/officeDocument/2006/customXml" ds:itemID="{ECA1DA60-FB17-4EB5-97F4-62F99A1A733D}">
+  <ds:schemaRefs/>
+</ds:datastoreItem>
+</file>
+
+<file path=customXml/itemProps8.xml><?xml version="1.0" encoding="utf-8"?>
+<ds:datastoreItem xmlns:ds="http://schemas.openxmlformats.org/officeDocument/2006/customXml" ds:itemID="{3DB14396-8B0C-45B4-9B8F-11E9F605DE89}">
+  <ds:schemaRefs/>
+</ds:datastoreItem>
+</file>
+
+<file path=customXml/itemProps9.xml><?xml version="1.0" encoding="utf-8"?>
+<ds:datastoreItem xmlns:ds="http://schemas.openxmlformats.org/officeDocument/2006/customXml" ds:itemID="{C7696DC1-7A22-4198-A4D1-783EAEBC6DD4}">
+  <ds:schemaRefs>
+    <ds:schemaRef ds:uri="http://schemas.microsoft.com/office/2006/metadata/properties"/>
+    <ds:schemaRef ds:uri="http://schemas.microsoft.com/office/infopath/2007/PartnerControls"/>
+  </ds:schemaRefs>
+</ds:datastoreItem>
 </file>
</xml_diff>

<commit_message>
updated extrapolation part of presentation
</commit_message>
<xml_diff>
--- a/meeting_notes/thesis.pptx
+++ b/meeting_notes/thesis.pptx
@@ -5,10 +5,10 @@
     <p:sldMasterId id="2147483662" r:id="rId12"/>
   </p:sldMasterIdLst>
   <p:notesMasterIdLst>
-    <p:notesMasterId r:id="rId23"/>
+    <p:notesMasterId r:id="rId25"/>
   </p:notesMasterIdLst>
   <p:handoutMasterIdLst>
-    <p:handoutMasterId r:id="rId24"/>
+    <p:handoutMasterId r:id="rId26"/>
   </p:handoutMasterIdLst>
   <p:sldIdLst>
     <p:sldId id="256" r:id="rId13"/>
@@ -20,12 +20,14 @@
     <p:sldId id="267" r:id="rId19"/>
     <p:sldId id="266" r:id="rId20"/>
     <p:sldId id="268" r:id="rId21"/>
-    <p:sldId id="269" r:id="rId22"/>
+    <p:sldId id="270" r:id="rId22"/>
+    <p:sldId id="271" r:id="rId23"/>
+    <p:sldId id="269" r:id="rId24"/>
   </p:sldIdLst>
   <p:sldSz cx="12190413" cy="6858000"/>
   <p:notesSz cx="6858000" cy="9144000"/>
   <p:custDataLst>
-    <p:tags r:id="rId25"/>
+    <p:tags r:id="rId27"/>
   </p:custDataLst>
   <p:defaultTextStyle>
     <a:defPPr>
@@ -166,6 +168,8 @@
             <p14:sldId id="267"/>
             <p14:sldId id="266"/>
             <p14:sldId id="268"/>
+            <p14:sldId id="270"/>
+            <p14:sldId id="271"/>
             <p14:sldId id="269"/>
           </p14:sldIdLst>
         </p14:section>
@@ -9271,7 +9275,7 @@
           <p:cNvPr id="2" name="Title 1">
             <a:extLst>
               <a:ext uri="{FF2B5EF4-FFF2-40B4-BE49-F238E27FC236}">
-                <a16:creationId xmlns:a16="http://schemas.microsoft.com/office/drawing/2014/main" id="{73C8BF9C-AF28-35C5-4296-A31EBD8E60CD}"/>
+                <a16:creationId xmlns:a16="http://schemas.microsoft.com/office/drawing/2014/main" id="{1886E884-C6AB-30FD-C4BF-4C3DF3C9B9B1}"/>
               </a:ext>
             </a:extLst>
           </p:cNvPr>
@@ -9287,18 +9291,7 @@
           <a:bodyPr/>
           <a:lstStyle/>
           <a:p>
-            <a:r>
-              <a:rPr lang="en-US" dirty="0"/>
-              <a:t>Adaptive </a:t>
-            </a:r>
-            <a:r>
-              <a:rPr lang="en-US" dirty="0" err="1"/>
-              <a:t>kNN</a:t>
-            </a:r>
-            <a:r>
-              <a:rPr lang="en-US" dirty="0"/>
-              <a:t> for reduced corner-edge pair influence</a:t>
-            </a:r>
+            <a:endParaRPr lang="da-DK"/>
           </a:p>
         </p:txBody>
       </p:sp>
@@ -9307,7 +9300,7 @@
           <p:cNvPr id="3" name="Content Placeholder 2">
             <a:extLst>
               <a:ext uri="{FF2B5EF4-FFF2-40B4-BE49-F238E27FC236}">
-                <a16:creationId xmlns:a16="http://schemas.microsoft.com/office/drawing/2014/main" id="{A00616BD-AFEA-51C2-E003-9F8F163E1970}"/>
+                <a16:creationId xmlns:a16="http://schemas.microsoft.com/office/drawing/2014/main" id="{2FF0FE57-6131-4F12-203A-F754D93730E9}"/>
               </a:ext>
             </a:extLst>
           </p:cNvPr>
@@ -9323,7 +9316,7 @@
           <a:bodyPr/>
           <a:lstStyle/>
           <a:p>
-            <a:endParaRPr lang="en-US" dirty="0"/>
+            <a:endParaRPr lang="da-DK"/>
           </a:p>
         </p:txBody>
       </p:sp>
@@ -9332,7 +9325,7 @@
           <p:cNvPr id="4" name="Picture Placeholder 3">
             <a:extLst>
               <a:ext uri="{FF2B5EF4-FFF2-40B4-BE49-F238E27FC236}">
-                <a16:creationId xmlns:a16="http://schemas.microsoft.com/office/drawing/2014/main" id="{F1B0247E-BF4F-914E-A199-205A079C003B}"/>
+                <a16:creationId xmlns:a16="http://schemas.microsoft.com/office/drawing/2014/main" id="{98824BF3-88B5-757F-B9BB-E6D168CB6718}"/>
               </a:ext>
             </a:extLst>
           </p:cNvPr>
@@ -9348,11 +9341,7 @@
           <a:bodyPr/>
           <a:lstStyle/>
           <a:p>
-            <a:pPr marL="171450" indent="-171450" algn="l">
-              <a:buFont typeface="Arial" panose="020B0604020202020204" pitchFamily="34" charset="0"/>
-              <a:buChar char="•"/>
-            </a:pPr>
-            <a:endParaRPr lang="en-US" dirty="0"/>
+            <a:endParaRPr lang="da-DK"/>
           </a:p>
         </p:txBody>
       </p:sp>
@@ -9361,7 +9350,7 @@
           <p:cNvPr id="5" name="Picture Placeholder 4">
             <a:extLst>
               <a:ext uri="{FF2B5EF4-FFF2-40B4-BE49-F238E27FC236}">
-                <a16:creationId xmlns:a16="http://schemas.microsoft.com/office/drawing/2014/main" id="{C50ED98A-2745-57DC-1B1A-1697A019F6C5}"/>
+                <a16:creationId xmlns:a16="http://schemas.microsoft.com/office/drawing/2014/main" id="{8C3A0549-390B-D061-E5CD-47047B35A2A4}"/>
               </a:ext>
             </a:extLst>
           </p:cNvPr>
@@ -9377,7 +9366,7 @@
           <a:bodyPr/>
           <a:lstStyle/>
           <a:p>
-            <a:endParaRPr lang="en-US"/>
+            <a:endParaRPr lang="da-DK"/>
           </a:p>
         </p:txBody>
       </p:sp>
@@ -9386,7 +9375,7 @@
           <p:cNvPr id="6" name="Footer Placeholder 5">
             <a:extLst>
               <a:ext uri="{FF2B5EF4-FFF2-40B4-BE49-F238E27FC236}">
-                <a16:creationId xmlns:a16="http://schemas.microsoft.com/office/drawing/2014/main" id="{FB2ACDD2-10FE-2183-51A8-DB43B1FE0035}"/>
+                <a16:creationId xmlns:a16="http://schemas.microsoft.com/office/drawing/2014/main" id="{4B356757-1DA5-437F-6123-0C8A56AE2B33}"/>
               </a:ext>
             </a:extLst>
           </p:cNvPr>
@@ -9415,7 +9404,7 @@
           <p:cNvPr id="7" name="Slide Number Placeholder 6">
             <a:extLst>
               <a:ext uri="{FF2B5EF4-FFF2-40B4-BE49-F238E27FC236}">
-                <a16:creationId xmlns:a16="http://schemas.microsoft.com/office/drawing/2014/main" id="{34708970-D1AB-D116-C600-75A4487E7A3C}"/>
+                <a16:creationId xmlns:a16="http://schemas.microsoft.com/office/drawing/2014/main" id="{D074543C-2894-244F-24C5-AD0C42B611A6}"/>
               </a:ext>
             </a:extLst>
           </p:cNvPr>
@@ -9445,7 +9434,7 @@
           <p:cNvPr id="8" name="Date Placeholder 7">
             <a:extLst>
               <a:ext uri="{FF2B5EF4-FFF2-40B4-BE49-F238E27FC236}">
-                <a16:creationId xmlns:a16="http://schemas.microsoft.com/office/drawing/2014/main" id="{1A21B963-7E9A-74CB-41AB-D0E4FC6EAFFC}"/>
+                <a16:creationId xmlns:a16="http://schemas.microsoft.com/office/drawing/2014/main" id="{60E947D9-B4E6-F3FE-AD9F-8D6BBBA94B7E}"/>
               </a:ext>
             </a:extLst>
           </p:cNvPr>
@@ -9469,6 +9458,929 @@
           </a:p>
         </p:txBody>
       </p:sp>
+    </p:spTree>
+    <p:extLst>
+      <p:ext uri="{BB962C8B-B14F-4D97-AF65-F5344CB8AC3E}">
+        <p14:creationId xmlns:p14="http://schemas.microsoft.com/office/powerpoint/2010/main" val="1083310755"/>
+      </p:ext>
+    </p:extLst>
+  </p:cSld>
+  <p:clrMapOvr>
+    <a:masterClrMapping/>
+  </p:clrMapOvr>
+</p:sld>
+</file>
+
+<file path=ppt/slides/slide11.xml><?xml version="1.0" encoding="utf-8"?>
+<p:sld xmlns:a="http://schemas.openxmlformats.org/drawingml/2006/main" xmlns:r="http://schemas.openxmlformats.org/officeDocument/2006/relationships" xmlns:p="http://schemas.openxmlformats.org/presentationml/2006/main">
+  <p:cSld>
+    <p:spTree>
+      <p:nvGrpSpPr>
+        <p:cNvPr id="1" name=""/>
+        <p:cNvGrpSpPr/>
+        <p:nvPr/>
+      </p:nvGrpSpPr>
+      <p:grpSpPr>
+        <a:xfrm>
+          <a:off x="0" y="0"/>
+          <a:ext cx="0" cy="0"/>
+          <a:chOff x="0" y="0"/>
+          <a:chExt cx="0" cy="0"/>
+        </a:xfrm>
+      </p:grpSpPr>
+      <p:sp>
+        <p:nvSpPr>
+          <p:cNvPr id="2" name="Title 1">
+            <a:extLst>
+              <a:ext uri="{FF2B5EF4-FFF2-40B4-BE49-F238E27FC236}">
+                <a16:creationId xmlns:a16="http://schemas.microsoft.com/office/drawing/2014/main" id="{D4741C88-EE43-D40D-CA12-2994A72B88A9}"/>
+              </a:ext>
+            </a:extLst>
+          </p:cNvPr>
+          <p:cNvSpPr>
+            <a:spLocks noGrp="1"/>
+          </p:cNvSpPr>
+          <p:nvPr>
+            <p:ph type="title"/>
+          </p:nvPr>
+        </p:nvSpPr>
+        <p:spPr/>
+        <p:txBody>
+          <a:bodyPr/>
+          <a:lstStyle/>
+          <a:p>
+            <a:r>
+              <a:rPr lang="da-DK" dirty="0" err="1"/>
+              <a:t>Extrapolation</a:t>
+            </a:r>
+            <a:endParaRPr lang="da-DK" dirty="0"/>
+          </a:p>
+        </p:txBody>
+      </p:sp>
+      <p:pic>
+        <p:nvPicPr>
+          <p:cNvPr id="11" name="Content Placeholder 10">
+            <a:extLst>
+              <a:ext uri="{FF2B5EF4-FFF2-40B4-BE49-F238E27FC236}">
+                <a16:creationId xmlns:a16="http://schemas.microsoft.com/office/drawing/2014/main" id="{694FC054-ACAC-17FF-DB4F-3C7B7CD99891}"/>
+              </a:ext>
+            </a:extLst>
+          </p:cNvPr>
+          <p:cNvPicPr>
+            <a:picLocks noGrp="1" noChangeAspect="1"/>
+          </p:cNvPicPr>
+          <p:nvPr>
+            <p:ph sz="half" idx="1"/>
+          </p:nvPr>
+        </p:nvPicPr>
+        <p:blipFill>
+          <a:blip r:embed="rId2">
+            <a:extLst>
+              <a:ext uri="{28A0092B-C50C-407E-A947-70E740481C1C}">
+                <a14:useLocalDpi xmlns:a14="http://schemas.microsoft.com/office/drawing/2010/main" val="0"/>
+              </a:ext>
+            </a:extLst>
+          </a:blip>
+          <a:srcRect/>
+          <a:stretch/>
+        </p:blipFill>
+        <p:spPr bwMode="auto">
+          <a:xfrm>
+            <a:off x="1414686" y="2924944"/>
+            <a:ext cx="4410075" cy="3118552"/>
+          </a:xfrm>
+          <a:prstGeom prst="rect">
+            <a:avLst/>
+          </a:prstGeom>
+          <a:noFill/>
+          <a:ln>
+            <a:noFill/>
+          </a:ln>
+          <a:effectLst>
+            <a:outerShdw blurRad="63500" sx="102000" sy="102000" algn="ctr" rotWithShape="0">
+              <a:prstClr val="black">
+                <a:alpha val="40000"/>
+              </a:prstClr>
+            </a:outerShdw>
+          </a:effectLst>
+          <a:extLst>
+            <a:ext uri="{909E8E84-426E-40DD-AFC4-6F175D3DCCD1}">
+              <a14:hiddenFill xmlns:a14="http://schemas.microsoft.com/office/drawing/2010/main">
+                <a:solidFill>
+                  <a:schemeClr val="accent1"/>
+                </a:solidFill>
+              </a14:hiddenFill>
+            </a:ext>
+            <a:ext uri="{91240B29-F687-4F45-9708-019B960494DF}">
+              <a14:hiddenLine xmlns:a14="http://schemas.microsoft.com/office/drawing/2010/main" w="9525">
+                <a:solidFill>
+                  <a:schemeClr val="tx1"/>
+                </a:solidFill>
+                <a:miter lim="800000"/>
+                <a:headEnd/>
+                <a:tailEnd/>
+              </a14:hiddenLine>
+            </a:ext>
+          </a:extLst>
+        </p:spPr>
+      </p:pic>
+      <p:pic>
+        <p:nvPicPr>
+          <p:cNvPr id="9" name="Content Placeholder 8">
+            <a:extLst>
+              <a:ext uri="{FF2B5EF4-FFF2-40B4-BE49-F238E27FC236}">
+                <a16:creationId xmlns:a16="http://schemas.microsoft.com/office/drawing/2014/main" id="{8B5FB1ED-71BE-6D35-A153-691BC4DAF446}"/>
+              </a:ext>
+            </a:extLst>
+          </p:cNvPr>
+          <p:cNvPicPr>
+            <a:picLocks noGrp="1" noChangeAspect="1"/>
+          </p:cNvPicPr>
+          <p:nvPr>
+            <p:ph sz="half" idx="2"/>
+          </p:nvPr>
+        </p:nvPicPr>
+        <p:blipFill>
+          <a:blip r:embed="rId3"/>
+          <a:stretch>
+            <a:fillRect/>
+          </a:stretch>
+        </p:blipFill>
+        <p:spPr bwMode="auto">
+          <a:xfrm>
+            <a:off x="8147738" y="1398843"/>
+            <a:ext cx="3575012" cy="4546600"/>
+          </a:xfrm>
+          <a:prstGeom prst="rect">
+            <a:avLst/>
+          </a:prstGeom>
+          <a:noFill/>
+          <a:ln>
+            <a:noFill/>
+          </a:ln>
+          <a:effectLst>
+            <a:outerShdw blurRad="63500" sx="102000" sy="102000" algn="ctr" rotWithShape="0">
+              <a:prstClr val="black">
+                <a:alpha val="40000"/>
+              </a:prstClr>
+            </a:outerShdw>
+          </a:effectLst>
+          <a:extLst>
+            <a:ext uri="{909E8E84-426E-40DD-AFC4-6F175D3DCCD1}">
+              <a14:hiddenFill xmlns:a14="http://schemas.microsoft.com/office/drawing/2010/main">
+                <a:solidFill>
+                  <a:schemeClr val="accent1"/>
+                </a:solidFill>
+              </a14:hiddenFill>
+            </a:ext>
+            <a:ext uri="{91240B29-F687-4F45-9708-019B960494DF}">
+              <a14:hiddenLine xmlns:a14="http://schemas.microsoft.com/office/drawing/2010/main" w="9525">
+                <a:solidFill>
+                  <a:schemeClr val="tx1"/>
+                </a:solidFill>
+                <a:miter lim="800000"/>
+                <a:headEnd/>
+                <a:tailEnd/>
+              </a14:hiddenLine>
+            </a:ext>
+          </a:extLst>
+        </p:spPr>
+      </p:pic>
+      <p:sp>
+        <p:nvSpPr>
+          <p:cNvPr id="5" name="Footer Placeholder 4">
+            <a:extLst>
+              <a:ext uri="{FF2B5EF4-FFF2-40B4-BE49-F238E27FC236}">
+                <a16:creationId xmlns:a16="http://schemas.microsoft.com/office/drawing/2014/main" id="{E186DCEA-BD3A-93D2-8EDD-9850D566A315}"/>
+              </a:ext>
+            </a:extLst>
+          </p:cNvPr>
+          <p:cNvSpPr>
+            <a:spLocks noGrp="1"/>
+          </p:cNvSpPr>
+          <p:nvPr>
+            <p:ph type="ftr" sz="quarter" idx="10"/>
+          </p:nvPr>
+        </p:nvSpPr>
+        <p:spPr/>
+        <p:txBody>
+          <a:bodyPr/>
+          <a:lstStyle/>
+          <a:p>
+            <a:r>
+              <a:rPr lang="en-GB"/>
+              <a:t>Title</a:t>
+            </a:r>
+            <a:endParaRPr lang="en-GB" dirty="0"/>
+          </a:p>
+        </p:txBody>
+      </p:sp>
+      <p:sp>
+        <p:nvSpPr>
+          <p:cNvPr id="6" name="Slide Number Placeholder 5">
+            <a:extLst>
+              <a:ext uri="{FF2B5EF4-FFF2-40B4-BE49-F238E27FC236}">
+                <a16:creationId xmlns:a16="http://schemas.microsoft.com/office/drawing/2014/main" id="{30CBE7F5-F27B-90CC-4C29-A6F9DF538F18}"/>
+              </a:ext>
+            </a:extLst>
+          </p:cNvPr>
+          <p:cNvSpPr>
+            <a:spLocks noGrp="1"/>
+          </p:cNvSpPr>
+          <p:nvPr>
+            <p:ph type="sldNum" sz="quarter" idx="11"/>
+          </p:nvPr>
+        </p:nvSpPr>
+        <p:spPr/>
+        <p:txBody>
+          <a:bodyPr/>
+          <a:lstStyle/>
+          <a:p>
+            <a:fld id="{103EA872-A674-449B-A120-B97244F8E91D}" type="slidenum">
+              <a:rPr lang="en-GB" smtClean="0"/>
+              <a:pPr/>
+              <a:t>11</a:t>
+            </a:fld>
+            <a:endParaRPr lang="en-GB" dirty="0"/>
+          </a:p>
+        </p:txBody>
+      </p:sp>
+      <p:sp>
+        <p:nvSpPr>
+          <p:cNvPr id="7" name="Date Placeholder 6">
+            <a:extLst>
+              <a:ext uri="{FF2B5EF4-FFF2-40B4-BE49-F238E27FC236}">
+                <a16:creationId xmlns:a16="http://schemas.microsoft.com/office/drawing/2014/main" id="{2A344174-83B8-7305-3339-9924124454A3}"/>
+              </a:ext>
+            </a:extLst>
+          </p:cNvPr>
+          <p:cNvSpPr>
+            <a:spLocks noGrp="1"/>
+          </p:cNvSpPr>
+          <p:nvPr>
+            <p:ph type="dt" sz="half" idx="12"/>
+          </p:nvPr>
+        </p:nvSpPr>
+        <p:spPr/>
+        <p:txBody>
+          <a:bodyPr/>
+          <a:lstStyle/>
+          <a:p>
+            <a:r>
+              <a:rPr lang="da-DK"/>
+              <a:t>Date</a:t>
+            </a:r>
+            <a:endParaRPr lang="en-GB"/>
+          </a:p>
+        </p:txBody>
+      </p:sp>
+      <p:sp>
+        <p:nvSpPr>
+          <p:cNvPr id="12" name="TextBox 11">
+            <a:extLst>
+              <a:ext uri="{FF2B5EF4-FFF2-40B4-BE49-F238E27FC236}">
+                <a16:creationId xmlns:a16="http://schemas.microsoft.com/office/drawing/2014/main" id="{C94D792E-7D15-BE25-A7DF-66303694477C}"/>
+              </a:ext>
+            </a:extLst>
+          </p:cNvPr>
+          <p:cNvSpPr txBox="1"/>
+          <p:nvPr/>
+        </p:nvSpPr>
+        <p:spPr>
+          <a:xfrm>
+            <a:off x="8971641" y="912485"/>
+            <a:ext cx="1440225" cy="246221"/>
+          </a:xfrm>
+          <a:prstGeom prst="rect">
+            <a:avLst/>
+          </a:prstGeom>
+          <a:noFill/>
+        </p:spPr>
+        <p:txBody>
+          <a:bodyPr wrap="square" lIns="0" tIns="0" rIns="0" bIns="0" rtlCol="0">
+            <a:spAutoFit/>
+          </a:bodyPr>
+          <a:lstStyle/>
+          <a:p>
+            <a:pPr algn="l">
+              <a:spcBef>
+                <a:spcPts val="432"/>
+              </a:spcBef>
+            </a:pPr>
+            <a:r>
+              <a:rPr lang="da-DK" dirty="0">
+                <a:latin typeface="+mn-lt"/>
+              </a:rPr>
+              <a:t>Using NC </a:t>
+            </a:r>
+          </a:p>
+        </p:txBody>
+      </p:sp>
+      <p:sp>
+        <p:nvSpPr>
+          <p:cNvPr id="13" name="TextBox 12">
+            <a:extLst>
+              <a:ext uri="{FF2B5EF4-FFF2-40B4-BE49-F238E27FC236}">
+                <a16:creationId xmlns:a16="http://schemas.microsoft.com/office/drawing/2014/main" id="{C2A8E0A6-E2A0-10CC-0269-13FC6E0A1298}"/>
+              </a:ext>
+            </a:extLst>
+          </p:cNvPr>
+          <p:cNvSpPr txBox="1"/>
+          <p:nvPr/>
+        </p:nvSpPr>
+        <p:spPr>
+          <a:xfrm>
+            <a:off x="1545085" y="1988840"/>
+            <a:ext cx="4010014" cy="543739"/>
+          </a:xfrm>
+          <a:prstGeom prst="rect">
+            <a:avLst/>
+          </a:prstGeom>
+          <a:noFill/>
+        </p:spPr>
+        <p:txBody>
+          <a:bodyPr wrap="square" lIns="0" tIns="0" rIns="0" bIns="0" rtlCol="0">
+            <a:spAutoFit/>
+          </a:bodyPr>
+          <a:lstStyle/>
+          <a:p>
+            <a:pPr marL="285750" indent="-285750" algn="l">
+              <a:spcBef>
+                <a:spcPts val="432"/>
+              </a:spcBef>
+              <a:buFont typeface="Arial" panose="020B0604020202020204" pitchFamily="34" charset="0"/>
+              <a:buChar char="•"/>
+            </a:pPr>
+            <a:r>
+              <a:rPr lang="da-DK" dirty="0" err="1">
+                <a:latin typeface="+mn-lt"/>
+              </a:rPr>
+              <a:t>kNN</a:t>
+            </a:r>
+            <a:r>
+              <a:rPr lang="da-DK" dirty="0">
+                <a:latin typeface="+mn-lt"/>
+              </a:rPr>
+              <a:t>: </a:t>
+            </a:r>
+            <a:r>
+              <a:rPr lang="da-DK" dirty="0" err="1">
+                <a:latin typeface="+mn-lt"/>
+              </a:rPr>
+              <a:t>Finding</a:t>
+            </a:r>
+            <a:r>
+              <a:rPr lang="da-DK" dirty="0">
+                <a:latin typeface="+mn-lt"/>
+              </a:rPr>
+              <a:t> </a:t>
+            </a:r>
+            <a:r>
+              <a:rPr lang="da-DK" dirty="0" err="1">
+                <a:latin typeface="+mn-lt"/>
+              </a:rPr>
+              <a:t>equivalent</a:t>
+            </a:r>
+            <a:r>
+              <a:rPr lang="da-DK" dirty="0">
+                <a:latin typeface="+mn-lt"/>
+              </a:rPr>
+              <a:t> </a:t>
+            </a:r>
+            <a:r>
+              <a:rPr lang="da-DK" dirty="0" err="1">
+                <a:latin typeface="+mn-lt"/>
+              </a:rPr>
+              <a:t>centroids</a:t>
+            </a:r>
+            <a:endParaRPr lang="da-DK" dirty="0">
+              <a:latin typeface="+mn-lt"/>
+            </a:endParaRPr>
+          </a:p>
+          <a:p>
+            <a:pPr marL="285750" indent="-285750" algn="l">
+              <a:spcBef>
+                <a:spcPts val="432"/>
+              </a:spcBef>
+              <a:buFont typeface="Arial" panose="020B0604020202020204" pitchFamily="34" charset="0"/>
+              <a:buChar char="•"/>
+            </a:pPr>
+            <a:r>
+              <a:rPr lang="da-DK" dirty="0">
+                <a:latin typeface="+mn-lt"/>
+              </a:rPr>
+              <a:t>In practice: </a:t>
+            </a:r>
+            <a:r>
+              <a:rPr lang="da-DK" dirty="0" err="1">
+                <a:latin typeface="+mn-lt"/>
+              </a:rPr>
+              <a:t>only</a:t>
+            </a:r>
+            <a:r>
+              <a:rPr lang="da-DK" dirty="0">
+                <a:latin typeface="+mn-lt"/>
+              </a:rPr>
+              <a:t> </a:t>
+            </a:r>
+            <a:r>
+              <a:rPr lang="da-DK" dirty="0" err="1">
+                <a:latin typeface="+mn-lt"/>
+              </a:rPr>
+              <a:t>one</a:t>
+            </a:r>
+            <a:r>
+              <a:rPr lang="da-DK" dirty="0">
+                <a:latin typeface="+mn-lt"/>
+              </a:rPr>
+              <a:t> </a:t>
+            </a:r>
+            <a:r>
+              <a:rPr lang="da-DK" dirty="0" err="1">
+                <a:latin typeface="+mn-lt"/>
+              </a:rPr>
+              <a:t>edge</a:t>
+            </a:r>
+            <a:r>
+              <a:rPr lang="da-DK" dirty="0">
+                <a:latin typeface="+mn-lt"/>
+              </a:rPr>
+              <a:t> at a time</a:t>
+            </a:r>
+          </a:p>
+        </p:txBody>
+      </p:sp>
+    </p:spTree>
+    <p:extLst>
+      <p:ext uri="{BB962C8B-B14F-4D97-AF65-F5344CB8AC3E}">
+        <p14:creationId xmlns:p14="http://schemas.microsoft.com/office/powerpoint/2010/main" val="2420928599"/>
+      </p:ext>
+    </p:extLst>
+  </p:cSld>
+  <p:clrMapOvr>
+    <a:masterClrMapping/>
+  </p:clrMapOvr>
+</p:sld>
+</file>
+
+<file path=ppt/slides/slide12.xml><?xml version="1.0" encoding="utf-8"?>
+<p:sld xmlns:a="http://schemas.openxmlformats.org/drawingml/2006/main" xmlns:r="http://schemas.openxmlformats.org/officeDocument/2006/relationships" xmlns:p="http://schemas.openxmlformats.org/presentationml/2006/main">
+  <p:cSld>
+    <p:spTree>
+      <p:nvGrpSpPr>
+        <p:cNvPr id="1" name=""/>
+        <p:cNvGrpSpPr/>
+        <p:nvPr/>
+      </p:nvGrpSpPr>
+      <p:grpSpPr>
+        <a:xfrm>
+          <a:off x="0" y="0"/>
+          <a:ext cx="0" cy="0"/>
+          <a:chOff x="0" y="0"/>
+          <a:chExt cx="0" cy="0"/>
+        </a:xfrm>
+      </p:grpSpPr>
+      <p:sp>
+        <p:nvSpPr>
+          <p:cNvPr id="2" name="Title 1">
+            <a:extLst>
+              <a:ext uri="{FF2B5EF4-FFF2-40B4-BE49-F238E27FC236}">
+                <a16:creationId xmlns:a16="http://schemas.microsoft.com/office/drawing/2014/main" id="{73C8BF9C-AF28-35C5-4296-A31EBD8E60CD}"/>
+              </a:ext>
+            </a:extLst>
+          </p:cNvPr>
+          <p:cNvSpPr>
+            <a:spLocks noGrp="1"/>
+          </p:cNvSpPr>
+          <p:nvPr>
+            <p:ph type="title"/>
+          </p:nvPr>
+        </p:nvSpPr>
+        <p:spPr/>
+        <p:txBody>
+          <a:bodyPr/>
+          <a:lstStyle/>
+          <a:p>
+            <a:r>
+              <a:rPr lang="en-US" dirty="0"/>
+              <a:t>Adaptive </a:t>
+            </a:r>
+            <a:r>
+              <a:rPr lang="en-US" dirty="0" err="1"/>
+              <a:t>kNN</a:t>
+            </a:r>
+            <a:r>
+              <a:rPr lang="en-US" dirty="0"/>
+              <a:t> for reduced corner-edge pair influence</a:t>
+            </a:r>
+          </a:p>
+        </p:txBody>
+      </p:sp>
+      <p:pic>
+        <p:nvPicPr>
+          <p:cNvPr id="10" name="Content Placeholder 9">
+            <a:extLst>
+              <a:ext uri="{FF2B5EF4-FFF2-40B4-BE49-F238E27FC236}">
+                <a16:creationId xmlns:a16="http://schemas.microsoft.com/office/drawing/2014/main" id="{BCA5C2A9-BF3C-1249-E1AA-2032E0858E32}"/>
+              </a:ext>
+            </a:extLst>
+          </p:cNvPr>
+          <p:cNvPicPr>
+            <a:picLocks noGrp="1" noChangeAspect="1"/>
+          </p:cNvPicPr>
+          <p:nvPr>
+            <p:ph idx="1"/>
+          </p:nvPr>
+        </p:nvPicPr>
+        <p:blipFill rotWithShape="1">
+          <a:blip r:embed="rId2"/>
+          <a:srcRect l="14287" t="13143" r="10711" b="13638"/>
+          <a:stretch>
+            <a:fillRect/>
+          </a:stretch>
+        </p:blipFill>
+        <p:spPr bwMode="auto">
+          <a:xfrm>
+            <a:off x="406574" y="1628800"/>
+            <a:ext cx="6563224" cy="4271304"/>
+          </a:xfrm>
+          <a:prstGeom prst="rect">
+            <a:avLst/>
+          </a:prstGeom>
+          <a:noFill/>
+          <a:ln>
+            <a:noFill/>
+          </a:ln>
+          <a:effectLst>
+            <a:outerShdw blurRad="63500" sx="102000" sy="102000" algn="ctr" rotWithShape="0">
+              <a:prstClr val="black">
+                <a:alpha val="40000"/>
+              </a:prstClr>
+            </a:outerShdw>
+          </a:effectLst>
+          <a:extLst>
+            <a:ext uri="{909E8E84-426E-40DD-AFC4-6F175D3DCCD1}">
+              <a14:hiddenFill xmlns:a14="http://schemas.microsoft.com/office/drawing/2010/main">
+                <a:solidFill>
+                  <a:schemeClr val="accent1"/>
+                </a:solidFill>
+              </a14:hiddenFill>
+            </a:ext>
+            <a:ext uri="{91240B29-F687-4F45-9708-019B960494DF}">
+              <a14:hiddenLine xmlns:a14="http://schemas.microsoft.com/office/drawing/2010/main" w="9525">
+                <a:solidFill>
+                  <a:schemeClr val="tx1"/>
+                </a:solidFill>
+                <a:miter lim="800000"/>
+                <a:headEnd/>
+                <a:tailEnd/>
+              </a14:hiddenLine>
+            </a:ext>
+          </a:extLst>
+        </p:spPr>
+      </p:pic>
+      <p:sp>
+        <p:nvSpPr>
+          <p:cNvPr id="6" name="Footer Placeholder 5">
+            <a:extLst>
+              <a:ext uri="{FF2B5EF4-FFF2-40B4-BE49-F238E27FC236}">
+                <a16:creationId xmlns:a16="http://schemas.microsoft.com/office/drawing/2014/main" id="{FB2ACDD2-10FE-2183-51A8-DB43B1FE0035}"/>
+              </a:ext>
+            </a:extLst>
+          </p:cNvPr>
+          <p:cNvSpPr>
+            <a:spLocks noGrp="1"/>
+          </p:cNvSpPr>
+          <p:nvPr>
+            <p:ph type="ftr" sz="quarter" idx="15"/>
+          </p:nvPr>
+        </p:nvSpPr>
+        <p:spPr/>
+        <p:txBody>
+          <a:bodyPr/>
+          <a:lstStyle/>
+          <a:p>
+            <a:r>
+              <a:rPr lang="en-GB"/>
+              <a:t>Title</a:t>
+            </a:r>
+            <a:endParaRPr lang="en-GB" dirty="0"/>
+          </a:p>
+        </p:txBody>
+      </p:sp>
+      <p:sp>
+        <p:nvSpPr>
+          <p:cNvPr id="7" name="Slide Number Placeholder 6">
+            <a:extLst>
+              <a:ext uri="{FF2B5EF4-FFF2-40B4-BE49-F238E27FC236}">
+                <a16:creationId xmlns:a16="http://schemas.microsoft.com/office/drawing/2014/main" id="{34708970-D1AB-D116-C600-75A4487E7A3C}"/>
+              </a:ext>
+            </a:extLst>
+          </p:cNvPr>
+          <p:cNvSpPr>
+            <a:spLocks noGrp="1"/>
+          </p:cNvSpPr>
+          <p:nvPr>
+            <p:ph type="sldNum" sz="quarter" idx="16"/>
+          </p:nvPr>
+        </p:nvSpPr>
+        <p:spPr/>
+        <p:txBody>
+          <a:bodyPr/>
+          <a:lstStyle/>
+          <a:p>
+            <a:fld id="{103EA872-A674-449B-A120-B97244F8E91D}" type="slidenum">
+              <a:rPr lang="en-GB" smtClean="0"/>
+              <a:pPr/>
+              <a:t>12</a:t>
+            </a:fld>
+            <a:endParaRPr lang="en-GB" dirty="0"/>
+          </a:p>
+        </p:txBody>
+      </p:sp>
+      <p:sp>
+        <p:nvSpPr>
+          <p:cNvPr id="8" name="Date Placeholder 7">
+            <a:extLst>
+              <a:ext uri="{FF2B5EF4-FFF2-40B4-BE49-F238E27FC236}">
+                <a16:creationId xmlns:a16="http://schemas.microsoft.com/office/drawing/2014/main" id="{1A21B963-7E9A-74CB-41AB-D0E4FC6EAFFC}"/>
+              </a:ext>
+            </a:extLst>
+          </p:cNvPr>
+          <p:cNvSpPr>
+            <a:spLocks noGrp="1"/>
+          </p:cNvSpPr>
+          <p:nvPr>
+            <p:ph type="dt" sz="half" idx="17"/>
+          </p:nvPr>
+        </p:nvSpPr>
+        <p:spPr/>
+        <p:txBody>
+          <a:bodyPr/>
+          <a:lstStyle/>
+          <a:p>
+            <a:r>
+              <a:rPr lang="da-DK"/>
+              <a:t>Date</a:t>
+            </a:r>
+            <a:endParaRPr lang="en-GB"/>
+          </a:p>
+        </p:txBody>
+      </p:sp>
+      <p:sp>
+        <p:nvSpPr>
+          <p:cNvPr id="11" name="Right Brace 10">
+            <a:extLst>
+              <a:ext uri="{FF2B5EF4-FFF2-40B4-BE49-F238E27FC236}">
+                <a16:creationId xmlns:a16="http://schemas.microsoft.com/office/drawing/2014/main" id="{581A152C-6A67-1BC4-4194-A0D9880A2F73}"/>
+              </a:ext>
+            </a:extLst>
+          </p:cNvPr>
+          <p:cNvSpPr/>
+          <p:nvPr/>
+        </p:nvSpPr>
+        <p:spPr bwMode="auto">
+          <a:xfrm rot="18095783">
+            <a:off x="2923291" y="4171908"/>
+            <a:ext cx="145171" cy="1273239"/>
+          </a:xfrm>
+          <a:prstGeom prst="rightBrace">
+            <a:avLst>
+              <a:gd name="adj1" fmla="val 39418"/>
+              <a:gd name="adj2" fmla="val 43830"/>
+            </a:avLst>
+          </a:prstGeom>
+          <a:noFill/>
+          <a:ln w="19050" cap="flat" cmpd="sng" algn="ctr">
+            <a:solidFill>
+              <a:schemeClr val="tx1"/>
+            </a:solidFill>
+            <a:prstDash val="solid"/>
+            <a:miter lim="800000"/>
+            <a:headEnd type="none" w="med" len="med"/>
+            <a:tailEnd type="none" w="med" len="med"/>
+          </a:ln>
+          <a:effectLst/>
+        </p:spPr>
+        <p:txBody>
+          <a:bodyPr rtlCol="0" anchor="ctr"/>
+          <a:lstStyle/>
+          <a:p>
+            <a:pPr algn="ctr"/>
+            <a:endParaRPr lang="da-DK"/>
+          </a:p>
+        </p:txBody>
+      </p:sp>
+      <p:cxnSp>
+        <p:nvCxnSpPr>
+          <p:cNvPr id="9" name="Straight Arrow Connector 8">
+            <a:extLst>
+              <a:ext uri="{FF2B5EF4-FFF2-40B4-BE49-F238E27FC236}">
+                <a16:creationId xmlns:a16="http://schemas.microsoft.com/office/drawing/2014/main" id="{5EAEC244-BD84-393F-411C-4FADA120F34B}"/>
+              </a:ext>
+            </a:extLst>
+          </p:cNvPr>
+          <p:cNvCxnSpPr>
+            <a:stCxn id="11" idx="1"/>
+          </p:cNvCxnSpPr>
+          <p:nvPr/>
+        </p:nvCxnSpPr>
+        <p:spPr bwMode="auto">
+          <a:xfrm flipV="1">
+            <a:off x="2966993" y="4437112"/>
+            <a:ext cx="175885" cy="268431"/>
+          </a:xfrm>
+          <a:prstGeom prst="straightConnector1">
+            <a:avLst/>
+          </a:prstGeom>
+          <a:solidFill>
+            <a:schemeClr val="accent1"/>
+          </a:solidFill>
+          <a:ln w="19050" cap="flat" cmpd="sng" algn="ctr">
+            <a:solidFill>
+              <a:schemeClr val="tx1"/>
+            </a:solidFill>
+            <a:prstDash val="solid"/>
+            <a:miter lim="800000"/>
+            <a:headEnd type="none" w="med" len="med"/>
+            <a:tailEnd type="triangle"/>
+          </a:ln>
+          <a:effectLst/>
+          <a:extLst>
+            <a:ext uri="{AF507438-7753-43E0-B8FC-AC1667EBCBE1}">
+              <a14:hiddenEffects xmlns:a14="http://schemas.microsoft.com/office/drawing/2010/main">
+                <a:effectLst>
+                  <a:outerShdw dist="35921" dir="2700000" algn="ctr" rotWithShape="0">
+                    <a:schemeClr val="bg2"/>
+                  </a:outerShdw>
+                </a:effectLst>
+              </a14:hiddenEffects>
+            </a:ext>
+          </a:extLst>
+        </p:spPr>
+      </p:cxnSp>
+      <p:sp>
+        <p:nvSpPr>
+          <p:cNvPr id="17" name="Right Brace 16">
+            <a:extLst>
+              <a:ext uri="{FF2B5EF4-FFF2-40B4-BE49-F238E27FC236}">
+                <a16:creationId xmlns:a16="http://schemas.microsoft.com/office/drawing/2014/main" id="{FBDABC65-B888-136A-6AA9-B52821ED6EEC}"/>
+              </a:ext>
+            </a:extLst>
+          </p:cNvPr>
+          <p:cNvSpPr/>
+          <p:nvPr/>
+        </p:nvSpPr>
+        <p:spPr bwMode="auto">
+          <a:xfrm rot="18095783">
+            <a:off x="1715035" y="3468665"/>
+            <a:ext cx="96169" cy="1215465"/>
+          </a:xfrm>
+          <a:prstGeom prst="rightBrace">
+            <a:avLst>
+              <a:gd name="adj1" fmla="val 39418"/>
+              <a:gd name="adj2" fmla="val 77242"/>
+            </a:avLst>
+          </a:prstGeom>
+          <a:noFill/>
+          <a:ln w="19050" cap="flat" cmpd="sng" algn="ctr">
+            <a:solidFill>
+              <a:schemeClr val="tx1"/>
+            </a:solidFill>
+            <a:prstDash val="solid"/>
+            <a:miter lim="800000"/>
+            <a:headEnd type="none" w="med" len="med"/>
+            <a:tailEnd type="none" w="med" len="med"/>
+          </a:ln>
+          <a:effectLst/>
+        </p:spPr>
+        <p:txBody>
+          <a:bodyPr rtlCol="0" anchor="ctr"/>
+          <a:lstStyle/>
+          <a:p>
+            <a:pPr algn="ctr"/>
+            <a:endParaRPr lang="da-DK"/>
+          </a:p>
+        </p:txBody>
+      </p:sp>
+      <p:cxnSp>
+        <p:nvCxnSpPr>
+          <p:cNvPr id="18" name="Straight Arrow Connector 17">
+            <a:extLst>
+              <a:ext uri="{FF2B5EF4-FFF2-40B4-BE49-F238E27FC236}">
+                <a16:creationId xmlns:a16="http://schemas.microsoft.com/office/drawing/2014/main" id="{FA405748-5E43-8948-32D9-5333DBA31ED0}"/>
+              </a:ext>
+            </a:extLst>
+          </p:cNvPr>
+          <p:cNvCxnSpPr>
+            <a:cxnSpLocks/>
+            <a:stCxn id="17" idx="1"/>
+          </p:cNvCxnSpPr>
+          <p:nvPr/>
+        </p:nvCxnSpPr>
+        <p:spPr bwMode="auto">
+          <a:xfrm flipV="1">
+            <a:off x="2070344" y="4040395"/>
+            <a:ext cx="712494" cy="168529"/>
+          </a:xfrm>
+          <a:prstGeom prst="straightConnector1">
+            <a:avLst/>
+          </a:prstGeom>
+          <a:solidFill>
+            <a:schemeClr val="accent1"/>
+          </a:solidFill>
+          <a:ln w="19050" cap="flat" cmpd="sng" algn="ctr">
+            <a:solidFill>
+              <a:schemeClr val="tx1"/>
+            </a:solidFill>
+            <a:prstDash val="solid"/>
+            <a:miter lim="800000"/>
+            <a:headEnd type="none" w="med" len="med"/>
+            <a:tailEnd type="triangle"/>
+          </a:ln>
+          <a:effectLst/>
+          <a:extLst>
+            <a:ext uri="{AF507438-7753-43E0-B8FC-AC1667EBCBE1}">
+              <a14:hiddenEffects xmlns:a14="http://schemas.microsoft.com/office/drawing/2010/main">
+                <a:effectLst>
+                  <a:outerShdw dist="35921" dir="2700000" algn="ctr" rotWithShape="0">
+                    <a:schemeClr val="bg2"/>
+                  </a:outerShdw>
+                </a:effectLst>
+              </a14:hiddenEffects>
+            </a:ext>
+          </a:extLst>
+        </p:spPr>
+      </p:cxnSp>
+      <p:pic>
+        <p:nvPicPr>
+          <p:cNvPr id="23" name="Content Placeholder 10">
+            <a:extLst>
+              <a:ext uri="{FF2B5EF4-FFF2-40B4-BE49-F238E27FC236}">
+                <a16:creationId xmlns:a16="http://schemas.microsoft.com/office/drawing/2014/main" id="{49B553EC-1C86-974B-19E9-451C5681B5D6}"/>
+              </a:ext>
+            </a:extLst>
+          </p:cNvPr>
+          <p:cNvPicPr>
+            <a:picLocks noGrp="1" noChangeAspect="1"/>
+          </p:cNvPicPr>
+          <p:nvPr>
+            <p:ph type="pic" sz="quarter" idx="13"/>
+          </p:nvPr>
+        </p:nvPicPr>
+        <p:blipFill rotWithShape="1">
+          <a:blip r:embed="rId3">
+            <a:extLst>
+              <a:ext uri="{28A0092B-C50C-407E-A947-70E740481C1C}">
+                <a14:useLocalDpi xmlns:a14="http://schemas.microsoft.com/office/drawing/2010/main" val="0"/>
+              </a:ext>
+            </a:extLst>
+          </a:blip>
+          <a:srcRect t="-895" b="-2742"/>
+          <a:stretch>
+            <a:fillRect/>
+          </a:stretch>
+        </p:blipFill>
+        <p:spPr bwMode="auto">
+          <a:xfrm>
+            <a:off x="7871299" y="2281519"/>
+            <a:ext cx="3859213" cy="2871022"/>
+          </a:xfrm>
+          <a:prstGeom prst="rect">
+            <a:avLst/>
+          </a:prstGeom>
+          <a:noFill/>
+          <a:ln>
+            <a:noFill/>
+          </a:ln>
+          <a:effectLst>
+            <a:outerShdw blurRad="63500" sx="102000" sy="102000" algn="ctr" rotWithShape="0">
+              <a:prstClr val="black">
+                <a:alpha val="40000"/>
+              </a:prstClr>
+            </a:outerShdw>
+          </a:effectLst>
+          <a:extLst>
+            <a:ext uri="{909E8E84-426E-40DD-AFC4-6F175D3DCCD1}">
+              <a14:hiddenFill xmlns:a14="http://schemas.microsoft.com/office/drawing/2010/main">
+                <a:solidFill>
+                  <a:schemeClr val="accent1"/>
+                </a:solidFill>
+              </a14:hiddenFill>
+            </a:ext>
+            <a:ext uri="{91240B29-F687-4F45-9708-019B960494DF}">
+              <a14:hiddenLine xmlns:a14="http://schemas.microsoft.com/office/drawing/2010/main" w="9525">
+                <a:solidFill>
+                  <a:schemeClr val="tx1"/>
+                </a:solidFill>
+                <a:miter lim="800000"/>
+                <a:headEnd/>
+                <a:tailEnd/>
+              </a14:hiddenLine>
+            </a:ext>
+          </a:extLst>
+        </p:spPr>
+      </p:pic>
     </p:spTree>
     <p:extLst>
       <p:ext uri="{BB962C8B-B14F-4D97-AF65-F5344CB8AC3E}">
@@ -10052,7 +10964,7 @@
           <a:p>
             <a:r>
               <a:rPr lang="en-US" dirty="0"/>
-              <a:t>Investigate self-energies, z-NGR – onsite</a:t>
+              <a:t>Investigate self-energies, z-GNR – onsite</a:t>
             </a:r>
           </a:p>
         </p:txBody>
@@ -11196,7 +12108,7 @@
 </file>
 
 <file path=ppt/slides/slide8.xml><?xml version="1.0" encoding="utf-8"?>
-<p:sld xmlns:a="http://schemas.openxmlformats.org/drawingml/2006/main" xmlns:r="http://schemas.openxmlformats.org/officeDocument/2006/relationships" xmlns:p="http://schemas.openxmlformats.org/presentationml/2006/main">
+<p:sld xmlns:a="http://schemas.openxmlformats.org/drawingml/2006/main" xmlns:r="http://schemas.openxmlformats.org/officeDocument/2006/relationships" xmlns:p="http://schemas.openxmlformats.org/presentationml/2006/main" show="0">
   <p:cSld>
     <p:spTree>
       <p:nvGrpSpPr>
@@ -12048,7 +12960,7 @@
 </file>
 
 <file path=ppt/slides/slide9.xml><?xml version="1.0" encoding="utf-8"?>
-<p:sld xmlns:a="http://schemas.openxmlformats.org/drawingml/2006/main" xmlns:r="http://schemas.openxmlformats.org/officeDocument/2006/relationships" xmlns:p="http://schemas.openxmlformats.org/presentationml/2006/main">
+<p:sld xmlns:a="http://schemas.openxmlformats.org/drawingml/2006/main" xmlns:r="http://schemas.openxmlformats.org/officeDocument/2006/relationships" xmlns:p="http://schemas.openxmlformats.org/presentationml/2006/main" show="0">
   <p:cSld>
     <p:spTree>
       <p:nvGrpSpPr>
@@ -13413,7 +14325,7 @@
 </file>
 
 <file path=customXml/item1.xml><?xml version="1.0" encoding="utf-8"?>
-<TemplafySlideFormConfiguration><![CDATA[{"formFields":[],"formDataEntries":[]}]]></TemplafySlideFormConfiguration>
+<TemplafySlideTemplateConfiguration><![CDATA[{"elementsMetadata":[],"documentContentValidatorConfiguration":{"enableDocumentContentValidator":false,"documentContentValidatorVersion":0},"slideId":"636957682264057965","enableDocumentContentUpdater":true,"version":"1.2"}]]></TemplafySlideTemplateConfiguration>
 </file>
 
 <file path=customXml/item10.xml><?xml version="1.0" encoding="utf-8"?>
@@ -13421,11 +14333,16 @@
 </file>
 
 <file path=customXml/item11.xml><?xml version="1.0" encoding="utf-8"?>
-<TemplafySlideFormConfiguration><![CDATA[{"formFields":[],"formDataEntries":[]}]]></TemplafySlideFormConfiguration>
+<TemplafyTemplateConfiguration><![CDATA[{"elementsMetadata":[],"transformationConfigurations":[{"language":"{{DocumentLanguage}}","disableUpdates":false,"type":"proofingLanguage"}],"templateName":"DTU Template 16_9 - Purple","templateDescription":"","enableDocumentContentUpdater":true,"version":"1.2"}]]></TemplafyTemplateConfiguration>
 </file>
 
 <file path=customXml/item2.xml><?xml version="1.0" encoding="utf-8"?>
-<TemplafyTemplateConfiguration><![CDATA[{"elementsMetadata":[],"transformationConfigurations":[{"language":"{{DocumentLanguage}}","disableUpdates":false,"type":"proofingLanguage"}],"templateName":"DTU Template 16_9 - Purple","templateDescription":"","enableDocumentContentUpdater":true,"version":"1.2"}]]></TemplafyTemplateConfiguration>
+<?mso-contentType ?>
+<FormTemplates xmlns="http://schemas.microsoft.com/sharepoint/v3/contenttype/forms">
+  <Display>DocumentLibraryForm</Display>
+  <Edit>DocumentLibraryForm</Edit>
+  <New>DocumentLibraryForm</New>
+</FormTemplates>
 </file>
 
 <file path=customXml/item3.xml><?xml version="1.0" encoding="utf-8"?>
@@ -13437,12 +14354,7 @@
 </file>
 
 <file path=customXml/item5.xml><?xml version="1.0" encoding="utf-8"?>
-<?mso-contentType ?>
-<FormTemplates xmlns="http://schemas.microsoft.com/sharepoint/v3/contenttype/forms">
-  <Display>DocumentLibraryForm</Display>
-  <Edit>DocumentLibraryForm</Edit>
-  <New>DocumentLibraryForm</New>
-</FormTemplates>
+<TemplafySlideTemplateConfiguration><![CDATA[{"elementsMetadata":[],"documentContentValidatorConfiguration":{"enableDocumentContentValidator":false,"documentContentValidatorVersion":0},"slideId":"636957682264370159","enableDocumentContentUpdater":true,"version":"1.2"}]]></TemplafySlideTemplateConfiguration>
 </file>
 
 <file path=customXml/item6.xml><?xml version="1.0" encoding="utf-8"?>
@@ -13617,21 +14529,21 @@
 </file>
 
 <file path=customXml/item7.xml><?xml version="1.0" encoding="utf-8"?>
-<TemplafySlideTemplateConfiguration><![CDATA[{"elementsMetadata":[],"documentContentValidatorConfiguration":{"enableDocumentContentValidator":false,"documentContentValidatorVersion":0},"slideId":"636957682264057965","enableDocumentContentUpdater":true,"version":"1.2"}]]></TemplafySlideTemplateConfiguration>
-</file>
-
-<file path=customXml/item8.xml><?xml version="1.0" encoding="utf-8"?>
-<TemplafySlideTemplateConfiguration><![CDATA[{"elementsMetadata":[],"documentContentValidatorConfiguration":{"enableDocumentContentValidator":false,"documentContentValidatorVersion":0},"slideId":"636957682264370159","enableDocumentContentUpdater":true,"version":"1.2"}]]></TemplafySlideTemplateConfiguration>
-</file>
-
-<file path=customXml/item9.xml><?xml version="1.0" encoding="utf-8"?>
 <p:properties xmlns:p="http://schemas.microsoft.com/office/2006/metadata/properties" xmlns:xsi="http://www.w3.org/2001/XMLSchema-instance" xmlns:pc="http://schemas.microsoft.com/office/infopath/2007/PartnerControls">
   <documentManagement/>
 </p:properties>
 </file>
 
+<file path=customXml/item8.xml><?xml version="1.0" encoding="utf-8"?>
+<TemplafySlideFormConfiguration><![CDATA[{"formFields":[],"formDataEntries":[]}]]></TemplafySlideFormConfiguration>
+</file>
+
+<file path=customXml/item9.xml><?xml version="1.0" encoding="utf-8"?>
+<TemplafySlideFormConfiguration><![CDATA[{"formFields":[],"formDataEntries":[]}]]></TemplafySlideFormConfiguration>
+</file>
+
 <file path=customXml/itemProps1.xml><?xml version="1.0" encoding="utf-8"?>
-<ds:datastoreItem xmlns:ds="http://schemas.openxmlformats.org/officeDocument/2006/customXml" ds:itemID="{A24B75EB-8202-4907-9D1E-5F9CF0C29483}">
+<ds:datastoreItem xmlns:ds="http://schemas.openxmlformats.org/officeDocument/2006/customXml" ds:itemID="{ECA1DA60-FB17-4EB5-97F4-62F99A1A733D}">
   <ds:schemaRefs/>
 </ds:datastoreItem>
 </file>
@@ -13643,14 +14555,16 @@
 </file>
 
 <file path=customXml/itemProps11.xml><?xml version="1.0" encoding="utf-8"?>
-<ds:datastoreItem xmlns:ds="http://schemas.openxmlformats.org/officeDocument/2006/customXml" ds:itemID="{E618FA3B-8A67-40AE-8AE5-229504AB69D3}">
+<ds:datastoreItem xmlns:ds="http://schemas.openxmlformats.org/officeDocument/2006/customXml" ds:itemID="{1334258C-C3E7-4029-A615-C886A240FB15}">
   <ds:schemaRefs/>
 </ds:datastoreItem>
 </file>
 
 <file path=customXml/itemProps2.xml><?xml version="1.0" encoding="utf-8"?>
-<ds:datastoreItem xmlns:ds="http://schemas.openxmlformats.org/officeDocument/2006/customXml" ds:itemID="{1334258C-C3E7-4029-A615-C886A240FB15}">
-  <ds:schemaRefs/>
+<ds:datastoreItem xmlns:ds="http://schemas.openxmlformats.org/officeDocument/2006/customXml" ds:itemID="{3FAD9687-A325-465A-822F-98C7D264CFD7}">
+  <ds:schemaRefs>
+    <ds:schemaRef ds:uri="http://schemas.microsoft.com/sharepoint/v3/contenttype/forms"/>
+  </ds:schemaRefs>
 </ds:datastoreItem>
 </file>
 
@@ -13661,16 +14575,14 @@
 </file>
 
 <file path=customXml/itemProps4.xml><?xml version="1.0" encoding="utf-8"?>
-<ds:datastoreItem xmlns:ds="http://schemas.openxmlformats.org/officeDocument/2006/customXml" ds:itemID="{403BE795-51D5-47B5-B747-A10BFE22AFA8}">
+<ds:datastoreItem xmlns:ds="http://schemas.openxmlformats.org/officeDocument/2006/customXml" ds:itemID="{E618FA3B-8A67-40AE-8AE5-229504AB69D3}">
   <ds:schemaRefs/>
 </ds:datastoreItem>
 </file>
 
 <file path=customXml/itemProps5.xml><?xml version="1.0" encoding="utf-8"?>
-<ds:datastoreItem xmlns:ds="http://schemas.openxmlformats.org/officeDocument/2006/customXml" ds:itemID="{3FAD9687-A325-465A-822F-98C7D264CFD7}">
-  <ds:schemaRefs>
-    <ds:schemaRef ds:uri="http://schemas.microsoft.com/sharepoint/v3/contenttype/forms"/>
-  </ds:schemaRefs>
+<ds:datastoreItem xmlns:ds="http://schemas.openxmlformats.org/officeDocument/2006/customXml" ds:itemID="{3DB14396-8B0C-45B4-9B8F-11E9F605DE89}">
+  <ds:schemaRefs/>
 </ds:datastoreItem>
 </file>
 
@@ -13694,22 +14606,22 @@
 </file>
 
 <file path=customXml/itemProps7.xml><?xml version="1.0" encoding="utf-8"?>
-<ds:datastoreItem xmlns:ds="http://schemas.openxmlformats.org/officeDocument/2006/customXml" ds:itemID="{ECA1DA60-FB17-4EB5-97F4-62F99A1A733D}">
-  <ds:schemaRefs/>
-</ds:datastoreItem>
-</file>
-
-<file path=customXml/itemProps8.xml><?xml version="1.0" encoding="utf-8"?>
-<ds:datastoreItem xmlns:ds="http://schemas.openxmlformats.org/officeDocument/2006/customXml" ds:itemID="{3DB14396-8B0C-45B4-9B8F-11E9F605DE89}">
-  <ds:schemaRefs/>
-</ds:datastoreItem>
-</file>
-
-<file path=customXml/itemProps9.xml><?xml version="1.0" encoding="utf-8"?>
 <ds:datastoreItem xmlns:ds="http://schemas.openxmlformats.org/officeDocument/2006/customXml" ds:itemID="{C7696DC1-7A22-4198-A4D1-783EAEBC6DD4}">
   <ds:schemaRefs>
     <ds:schemaRef ds:uri="http://schemas.microsoft.com/office/2006/metadata/properties"/>
     <ds:schemaRef ds:uri="http://schemas.microsoft.com/office/infopath/2007/PartnerControls"/>
   </ds:schemaRefs>
 </ds:datastoreItem>
+</file>
+
+<file path=customXml/itemProps8.xml><?xml version="1.0" encoding="utf-8"?>
+<ds:datastoreItem xmlns:ds="http://schemas.openxmlformats.org/officeDocument/2006/customXml" ds:itemID="{403BE795-51D5-47B5-B747-A10BFE22AFA8}">
+  <ds:schemaRefs/>
+</ds:datastoreItem>
+</file>
+
+<file path=customXml/itemProps9.xml><?xml version="1.0" encoding="utf-8"?>
+<ds:datastoreItem xmlns:ds="http://schemas.openxmlformats.org/officeDocument/2006/customXml" ds:itemID="{A24B75EB-8202-4907-9D1E-5F9CF0C29483}">
+  <ds:schemaRefs/>
+</ds:datastoreItem>
 </file>
</xml_diff>

<commit_message>
inluded new transport data
</commit_message>
<xml_diff>
--- a/meeting_notes/thesis.pptx
+++ b/meeting_notes/thesis.pptx
@@ -5,10 +5,10 @@
     <p:sldMasterId id="2147483662" r:id="rId12"/>
   </p:sldMasterIdLst>
   <p:notesMasterIdLst>
-    <p:notesMasterId r:id="rId32"/>
+    <p:notesMasterId r:id="rId33"/>
   </p:notesMasterIdLst>
   <p:handoutMasterIdLst>
-    <p:handoutMasterId r:id="rId33"/>
+    <p:handoutMasterId r:id="rId34"/>
   </p:handoutMasterIdLst>
   <p:sldIdLst>
     <p:sldId id="256" r:id="rId13"/>
@@ -27,14 +27,15 @@
     <p:sldId id="273" r:id="rId26"/>
     <p:sldId id="274" r:id="rId27"/>
     <p:sldId id="275" r:id="rId28"/>
-    <p:sldId id="276" r:id="rId29"/>
-    <p:sldId id="277" r:id="rId30"/>
-    <p:sldId id="278" r:id="rId31"/>
+    <p:sldId id="279" r:id="rId29"/>
+    <p:sldId id="276" r:id="rId30"/>
+    <p:sldId id="277" r:id="rId31"/>
+    <p:sldId id="278" r:id="rId32"/>
   </p:sldIdLst>
   <p:sldSz cx="12190413" cy="6858000"/>
   <p:notesSz cx="6858000" cy="9144000"/>
   <p:custDataLst>
-    <p:tags r:id="rId34"/>
+    <p:tags r:id="rId35"/>
   </p:custDataLst>
   <p:defaultTextStyle>
     <a:defPPr>
@@ -182,6 +183,7 @@
             <p14:sldId id="273"/>
             <p14:sldId id="274"/>
             <p14:sldId id="275"/>
+            <p14:sldId id="279"/>
             <p14:sldId id="276"/>
             <p14:sldId id="277"/>
             <p14:sldId id="278"/>
@@ -11574,6 +11576,280 @@
         <p:cNvPr id="1" name="">
           <a:extLst>
             <a:ext uri="{FF2B5EF4-FFF2-40B4-BE49-F238E27FC236}">
+              <a16:creationId xmlns:a16="http://schemas.microsoft.com/office/drawing/2014/main" id="{AE09C534-D1D5-37DE-5A20-ACB6EAD260CA}"/>
+            </a:ext>
+          </a:extLst>
+        </p:cNvPr>
+        <p:cNvGrpSpPr/>
+        <p:nvPr/>
+      </p:nvGrpSpPr>
+      <p:grpSpPr>
+        <a:xfrm>
+          <a:off x="0" y="0"/>
+          <a:ext cx="0" cy="0"/>
+          <a:chOff x="0" y="0"/>
+          <a:chExt cx="0" cy="0"/>
+        </a:xfrm>
+      </p:grpSpPr>
+      <p:sp>
+        <p:nvSpPr>
+          <p:cNvPr id="2" name="Title 1">
+            <a:extLst>
+              <a:ext uri="{FF2B5EF4-FFF2-40B4-BE49-F238E27FC236}">
+                <a16:creationId xmlns:a16="http://schemas.microsoft.com/office/drawing/2014/main" id="{2381612C-29F3-12D5-59A0-0C152E6C0822}"/>
+              </a:ext>
+            </a:extLst>
+          </p:cNvPr>
+          <p:cNvSpPr>
+            <a:spLocks noGrp="1"/>
+          </p:cNvSpPr>
+          <p:nvPr>
+            <p:ph type="title"/>
+          </p:nvPr>
+        </p:nvSpPr>
+        <p:spPr/>
+        <p:txBody>
+          <a:bodyPr/>
+          <a:lstStyle/>
+          <a:p>
+            <a:r>
+              <a:rPr lang="da-DK" dirty="0"/>
+              <a:t>AA </a:t>
+            </a:r>
+            <a:r>
+              <a:rPr lang="da-DK" dirty="0" err="1"/>
+              <a:t>stacking</a:t>
+            </a:r>
+            <a:r>
+              <a:rPr lang="da-DK" dirty="0"/>
+              <a:t>, 16 atoms/UC Vs. 4 atoms/UC</a:t>
+            </a:r>
+          </a:p>
+        </p:txBody>
+      </p:sp>
+      <p:sp>
+        <p:nvSpPr>
+          <p:cNvPr id="6" name="Footer Placeholder 5">
+            <a:extLst>
+              <a:ext uri="{FF2B5EF4-FFF2-40B4-BE49-F238E27FC236}">
+                <a16:creationId xmlns:a16="http://schemas.microsoft.com/office/drawing/2014/main" id="{72FCC3EF-1F90-0770-435D-1D6E2D5B9177}"/>
+              </a:ext>
+            </a:extLst>
+          </p:cNvPr>
+          <p:cNvSpPr>
+            <a:spLocks noGrp="1"/>
+          </p:cNvSpPr>
+          <p:nvPr>
+            <p:ph type="ftr" sz="quarter" idx="10"/>
+          </p:nvPr>
+        </p:nvSpPr>
+        <p:spPr/>
+        <p:txBody>
+          <a:bodyPr/>
+          <a:lstStyle/>
+          <a:p>
+            <a:r>
+              <a:rPr lang="en-GB" dirty="0"/>
+              <a:t>Title</a:t>
+            </a:r>
+          </a:p>
+        </p:txBody>
+      </p:sp>
+      <p:sp>
+        <p:nvSpPr>
+          <p:cNvPr id="7" name="Slide Number Placeholder 6">
+            <a:extLst>
+              <a:ext uri="{FF2B5EF4-FFF2-40B4-BE49-F238E27FC236}">
+                <a16:creationId xmlns:a16="http://schemas.microsoft.com/office/drawing/2014/main" id="{3A50D42B-7E39-A7EA-7091-72E3D928F744}"/>
+              </a:ext>
+            </a:extLst>
+          </p:cNvPr>
+          <p:cNvSpPr>
+            <a:spLocks noGrp="1"/>
+          </p:cNvSpPr>
+          <p:nvPr>
+            <p:ph type="sldNum" sz="quarter" idx="11"/>
+          </p:nvPr>
+        </p:nvSpPr>
+        <p:spPr/>
+        <p:txBody>
+          <a:bodyPr/>
+          <a:lstStyle/>
+          <a:p>
+            <a:fld id="{103EA872-A674-449B-A120-B97244F8E91D}" type="slidenum">
+              <a:rPr lang="en-GB" smtClean="0"/>
+              <a:pPr/>
+              <a:t>17</a:t>
+            </a:fld>
+            <a:endParaRPr lang="en-GB" dirty="0"/>
+          </a:p>
+        </p:txBody>
+      </p:sp>
+      <p:sp>
+        <p:nvSpPr>
+          <p:cNvPr id="8" name="Date Placeholder 7">
+            <a:extLst>
+              <a:ext uri="{FF2B5EF4-FFF2-40B4-BE49-F238E27FC236}">
+                <a16:creationId xmlns:a16="http://schemas.microsoft.com/office/drawing/2014/main" id="{1C1B7A35-FCA3-9D84-C6FC-7380DBC22465}"/>
+              </a:ext>
+            </a:extLst>
+          </p:cNvPr>
+          <p:cNvSpPr>
+            <a:spLocks noGrp="1"/>
+          </p:cNvSpPr>
+          <p:nvPr>
+            <p:ph type="dt" sz="half" idx="12"/>
+          </p:nvPr>
+        </p:nvSpPr>
+        <p:spPr/>
+        <p:txBody>
+          <a:bodyPr/>
+          <a:lstStyle/>
+          <a:p>
+            <a:r>
+              <a:rPr lang="da-DK"/>
+              <a:t>Date</a:t>
+            </a:r>
+            <a:endParaRPr lang="en-GB"/>
+          </a:p>
+        </p:txBody>
+      </p:sp>
+      <p:pic>
+        <p:nvPicPr>
+          <p:cNvPr id="11" name="Content Placeholder 15">
+            <a:extLst>
+              <a:ext uri="{FF2B5EF4-FFF2-40B4-BE49-F238E27FC236}">
+                <a16:creationId xmlns:a16="http://schemas.microsoft.com/office/drawing/2014/main" id="{89C76A46-80A9-7359-35E8-1B0907658AE3}"/>
+              </a:ext>
+            </a:extLst>
+          </p:cNvPr>
+          <p:cNvPicPr>
+            <a:picLocks noGrp="1" noChangeAspect="1"/>
+          </p:cNvPicPr>
+          <p:nvPr>
+            <p:ph sz="half" idx="1"/>
+          </p:nvPr>
+        </p:nvPicPr>
+        <p:blipFill>
+          <a:blip r:embed="rId2">
+            <a:extLst>
+              <a:ext uri="{28A0092B-C50C-407E-A947-70E740481C1C}">
+                <a14:useLocalDpi xmlns:a14="http://schemas.microsoft.com/office/drawing/2010/main" val="0"/>
+              </a:ext>
+            </a:extLst>
+          </a:blip>
+          <a:srcRect/>
+          <a:stretch/>
+        </p:blipFill>
+        <p:spPr bwMode="auto">
+          <a:xfrm>
+            <a:off x="1774825" y="2320402"/>
+            <a:ext cx="4410075" cy="3318922"/>
+          </a:xfrm>
+          <a:prstGeom prst="rect">
+            <a:avLst/>
+          </a:prstGeom>
+          <a:noFill/>
+          <a:ln>
+            <a:noFill/>
+          </a:ln>
+          <a:extLst>
+            <a:ext uri="{909E8E84-426E-40DD-AFC4-6F175D3DCCD1}">
+              <a14:hiddenFill xmlns:a14="http://schemas.microsoft.com/office/drawing/2010/main">
+                <a:solidFill>
+                  <a:schemeClr val="accent1"/>
+                </a:solidFill>
+              </a14:hiddenFill>
+            </a:ext>
+            <a:ext uri="{91240B29-F687-4F45-9708-019B960494DF}">
+              <a14:hiddenLine xmlns:a14="http://schemas.microsoft.com/office/drawing/2010/main" w="9525">
+                <a:solidFill>
+                  <a:schemeClr val="tx1"/>
+                </a:solidFill>
+                <a:miter lim="800000"/>
+                <a:headEnd/>
+                <a:tailEnd/>
+              </a14:hiddenLine>
+            </a:ext>
+          </a:extLst>
+        </p:spPr>
+      </p:pic>
+      <p:pic>
+        <p:nvPicPr>
+          <p:cNvPr id="13" name="Content Placeholder 15">
+            <a:extLst>
+              <a:ext uri="{FF2B5EF4-FFF2-40B4-BE49-F238E27FC236}">
+                <a16:creationId xmlns:a16="http://schemas.microsoft.com/office/drawing/2014/main" id="{FAB1FFEF-0ECF-E86B-4C71-E65BDE8EA8C8}"/>
+              </a:ext>
+            </a:extLst>
+          </p:cNvPr>
+          <p:cNvPicPr>
+            <a:picLocks noGrp="1" noChangeAspect="1"/>
+          </p:cNvPicPr>
+          <p:nvPr>
+            <p:ph sz="half" idx="2"/>
+          </p:nvPr>
+        </p:nvPicPr>
+        <p:blipFill>
+          <a:blip r:embed="rId3"/>
+          <a:stretch>
+            <a:fillRect/>
+          </a:stretch>
+        </p:blipFill>
+        <p:spPr bwMode="auto">
+          <a:xfrm>
+            <a:off x="6678613" y="2328808"/>
+            <a:ext cx="4408487" cy="3302110"/>
+          </a:xfrm>
+          <a:prstGeom prst="rect">
+            <a:avLst/>
+          </a:prstGeom>
+          <a:noFill/>
+          <a:ln>
+            <a:noFill/>
+          </a:ln>
+          <a:extLst>
+            <a:ext uri="{909E8E84-426E-40DD-AFC4-6F175D3DCCD1}">
+              <a14:hiddenFill xmlns:a14="http://schemas.microsoft.com/office/drawing/2010/main">
+                <a:solidFill>
+                  <a:schemeClr val="accent1"/>
+                </a:solidFill>
+              </a14:hiddenFill>
+            </a:ext>
+            <a:ext uri="{91240B29-F687-4F45-9708-019B960494DF}">
+              <a14:hiddenLine xmlns:a14="http://schemas.microsoft.com/office/drawing/2010/main" w="9525">
+                <a:solidFill>
+                  <a:schemeClr val="tx1"/>
+                </a:solidFill>
+                <a:miter lim="800000"/>
+                <a:headEnd/>
+                <a:tailEnd/>
+              </a14:hiddenLine>
+            </a:ext>
+          </a:extLst>
+        </p:spPr>
+      </p:pic>
+    </p:spTree>
+    <p:extLst>
+      <p:ext uri="{BB962C8B-B14F-4D97-AF65-F5344CB8AC3E}">
+        <p14:creationId xmlns:p14="http://schemas.microsoft.com/office/powerpoint/2010/main" val="2919485757"/>
+      </p:ext>
+    </p:extLst>
+  </p:cSld>
+  <p:clrMapOvr>
+    <a:masterClrMapping/>
+  </p:clrMapOvr>
+</p:sld>
+</file>
+
+<file path=ppt/slides/slide18.xml><?xml version="1.0" encoding="utf-8"?>
+<p:sld xmlns:a="http://schemas.openxmlformats.org/drawingml/2006/main" xmlns:r="http://schemas.openxmlformats.org/officeDocument/2006/relationships" xmlns:p="http://schemas.openxmlformats.org/presentationml/2006/main">
+  <p:cSld>
+    <p:spTree>
+      <p:nvGrpSpPr>
+        <p:cNvPr id="1" name="">
+          <a:extLst>
+            <a:ext uri="{FF2B5EF4-FFF2-40B4-BE49-F238E27FC236}">
               <a16:creationId xmlns:a16="http://schemas.microsoft.com/office/drawing/2014/main" id="{DF63EE3F-DF04-5436-1CBE-FDFC6A09DB69}"/>
             </a:ext>
           </a:extLst>
@@ -11850,7 +12126,7 @@
             <a:fld id="{103EA872-A674-449B-A120-B97244F8E91D}" type="slidenum">
               <a:rPr lang="en-GB" smtClean="0"/>
               <a:pPr/>
-              <a:t>17</a:t>
+              <a:t>18</a:t>
             </a:fld>
             <a:endParaRPr lang="en-GB" dirty="0"/>
           </a:p>
@@ -11898,7 +12174,7 @@
 </p:sld>
 </file>
 
-<file path=ppt/slides/slide18.xml><?xml version="1.0" encoding="utf-8"?>
+<file path=ppt/slides/slide19.xml><?xml version="1.0" encoding="utf-8"?>
 <p:sld xmlns:a="http://schemas.openxmlformats.org/drawingml/2006/main" xmlns:r="http://schemas.openxmlformats.org/officeDocument/2006/relationships" xmlns:p="http://schemas.openxmlformats.org/presentationml/2006/main">
   <p:cSld>
     <p:spTree>
@@ -12182,7 +12458,7 @@
             <a:fld id="{103EA872-A674-449B-A120-B97244F8E91D}" type="slidenum">
               <a:rPr lang="en-GB" smtClean="0"/>
               <a:pPr/>
-              <a:t>18</a:t>
+              <a:t>19</a:t>
             </a:fld>
             <a:endParaRPr lang="en-GB" dirty="0"/>
           </a:p>
@@ -12230,7 +12506,183 @@
 </p:sld>
 </file>
 
-<file path=ppt/slides/slide19.xml><?xml version="1.0" encoding="utf-8"?>
+<file path=ppt/slides/slide2.xml><?xml version="1.0" encoding="utf-8"?>
+<p:sld xmlns:a="http://schemas.openxmlformats.org/drawingml/2006/main" xmlns:r="http://schemas.openxmlformats.org/officeDocument/2006/relationships" xmlns:p="http://schemas.openxmlformats.org/presentationml/2006/main">
+  <p:cSld>
+    <p:spTree>
+      <p:nvGrpSpPr>
+        <p:cNvPr id="1" name=""/>
+        <p:cNvGrpSpPr/>
+        <p:nvPr/>
+      </p:nvGrpSpPr>
+      <p:grpSpPr>
+        <a:xfrm>
+          <a:off x="0" y="0"/>
+          <a:ext cx="0" cy="0"/>
+          <a:chOff x="0" y="0"/>
+          <a:chExt cx="0" cy="0"/>
+        </a:xfrm>
+      </p:grpSpPr>
+      <p:sp>
+        <p:nvSpPr>
+          <p:cNvPr id="4" name="Title 3">
+            <a:extLst>
+              <a:ext uri="{FF2B5EF4-FFF2-40B4-BE49-F238E27FC236}">
+                <a16:creationId xmlns:a16="http://schemas.microsoft.com/office/drawing/2014/main" id="{674358EA-4D5B-461F-997D-DE6729900DE7}"/>
+              </a:ext>
+            </a:extLst>
+          </p:cNvPr>
+          <p:cNvSpPr>
+            <a:spLocks noGrp="1"/>
+          </p:cNvSpPr>
+          <p:nvPr>
+            <p:ph type="ctrTitle"/>
+          </p:nvPr>
+        </p:nvSpPr>
+        <p:spPr/>
+        <p:txBody>
+          <a:bodyPr/>
+          <a:lstStyle/>
+          <a:p>
+            <a:r>
+              <a:rPr lang="en-US" dirty="0"/>
+              <a:t>Scaling methods for QTM</a:t>
+            </a:r>
+            <a:endParaRPr lang="en-GB" dirty="0"/>
+          </a:p>
+        </p:txBody>
+      </p:sp>
+      <p:sp>
+        <p:nvSpPr>
+          <p:cNvPr id="5" name="Subtitle 4">
+            <a:extLst>
+              <a:ext uri="{FF2B5EF4-FFF2-40B4-BE49-F238E27FC236}">
+                <a16:creationId xmlns:a16="http://schemas.microsoft.com/office/drawing/2014/main" id="{88CE6942-A17C-4247-86C6-41FACF7E90AC}"/>
+              </a:ext>
+            </a:extLst>
+          </p:cNvPr>
+          <p:cNvSpPr>
+            <a:spLocks noGrp="1"/>
+          </p:cNvSpPr>
+          <p:nvPr>
+            <p:ph type="subTitle" idx="1"/>
+          </p:nvPr>
+        </p:nvSpPr>
+        <p:spPr/>
+        <p:txBody>
+          <a:bodyPr/>
+          <a:lstStyle/>
+          <a:p>
+            <a:endParaRPr lang="en-GB" dirty="0"/>
+          </a:p>
+        </p:txBody>
+      </p:sp>
+      <p:sp>
+        <p:nvSpPr>
+          <p:cNvPr id="2" name="Footer Placeholder 1">
+            <a:extLst>
+              <a:ext uri="{FF2B5EF4-FFF2-40B4-BE49-F238E27FC236}">
+                <a16:creationId xmlns:a16="http://schemas.microsoft.com/office/drawing/2014/main" id="{A45995EB-10E4-4119-B468-5CD7D10A0933}"/>
+              </a:ext>
+            </a:extLst>
+          </p:cNvPr>
+          <p:cNvSpPr>
+            <a:spLocks noGrp="1"/>
+          </p:cNvSpPr>
+          <p:nvPr>
+            <p:ph type="ftr" sz="quarter" idx="16"/>
+          </p:nvPr>
+        </p:nvSpPr>
+        <p:spPr/>
+        <p:txBody>
+          <a:bodyPr/>
+          <a:lstStyle/>
+          <a:p>
+            <a:r>
+              <a:rPr lang="en-GB"/>
+              <a:t>Title</a:t>
+            </a:r>
+            <a:endParaRPr lang="en-GB" dirty="0"/>
+          </a:p>
+        </p:txBody>
+      </p:sp>
+      <p:sp>
+        <p:nvSpPr>
+          <p:cNvPr id="3" name="Slide Number Placeholder 2">
+            <a:extLst>
+              <a:ext uri="{FF2B5EF4-FFF2-40B4-BE49-F238E27FC236}">
+                <a16:creationId xmlns:a16="http://schemas.microsoft.com/office/drawing/2014/main" id="{0AA221E4-1851-497D-90EE-984C7112166A}"/>
+              </a:ext>
+            </a:extLst>
+          </p:cNvPr>
+          <p:cNvSpPr>
+            <a:spLocks noGrp="1"/>
+          </p:cNvSpPr>
+          <p:nvPr>
+            <p:ph type="sldNum" sz="quarter" idx="17"/>
+          </p:nvPr>
+        </p:nvSpPr>
+        <p:spPr/>
+        <p:txBody>
+          <a:bodyPr/>
+          <a:lstStyle/>
+          <a:p>
+            <a:fld id="{24C8C45C-947F-4981-8B3F-4F32E973C901}" type="slidenum">
+              <a:rPr lang="en-GB" smtClean="0"/>
+              <a:pPr/>
+              <a:t>2</a:t>
+            </a:fld>
+            <a:endParaRPr lang="en-GB" dirty="0"/>
+          </a:p>
+        </p:txBody>
+      </p:sp>
+      <p:sp>
+        <p:nvSpPr>
+          <p:cNvPr id="6" name="Date Placeholder 5">
+            <a:extLst>
+              <a:ext uri="{FF2B5EF4-FFF2-40B4-BE49-F238E27FC236}">
+                <a16:creationId xmlns:a16="http://schemas.microsoft.com/office/drawing/2014/main" id="{6BD79507-030C-48B9-4B06-13AEB08862A3}"/>
+              </a:ext>
+            </a:extLst>
+          </p:cNvPr>
+          <p:cNvSpPr>
+            <a:spLocks noGrp="1"/>
+          </p:cNvSpPr>
+          <p:nvPr>
+            <p:ph type="dt" sz="half" idx="18"/>
+          </p:nvPr>
+        </p:nvSpPr>
+        <p:spPr/>
+        <p:txBody>
+          <a:bodyPr/>
+          <a:lstStyle/>
+          <a:p>
+            <a:r>
+              <a:rPr lang="da-DK"/>
+              <a:t>Date</a:t>
+            </a:r>
+            <a:endParaRPr lang="en-GB"/>
+          </a:p>
+        </p:txBody>
+      </p:sp>
+    </p:spTree>
+    <p:custDataLst>
+      <p:custData r:id="rId1"/>
+      <p:custData r:id="rId2"/>
+    </p:custDataLst>
+    <p:extLst>
+      <p:ext uri="{BB962C8B-B14F-4D97-AF65-F5344CB8AC3E}">
+        <p14:creationId xmlns:p14="http://schemas.microsoft.com/office/powerpoint/2010/main" val="2320714135"/>
+      </p:ext>
+    </p:extLst>
+  </p:cSld>
+  <p:clrMapOvr>
+    <a:masterClrMapping/>
+  </p:clrMapOvr>
+</p:sld>
+</file>
+
+<file path=ppt/slides/slide20.xml><?xml version="1.0" encoding="utf-8"?>
 <p:sld xmlns:a="http://schemas.openxmlformats.org/drawingml/2006/main" xmlns:r="http://schemas.openxmlformats.org/officeDocument/2006/relationships" xmlns:p="http://schemas.openxmlformats.org/presentationml/2006/main">
   <p:cSld>
     <p:spTree>
@@ -12514,7 +12966,7 @@
             <a:fld id="{103EA872-A674-449B-A120-B97244F8E91D}" type="slidenum">
               <a:rPr lang="en-GB" smtClean="0"/>
               <a:pPr/>
-              <a:t>19</a:t>
+              <a:t>20</a:t>
             </a:fld>
             <a:endParaRPr lang="en-GB" dirty="0"/>
           </a:p>
@@ -12553,182 +13005,6 @@
     <p:extLst>
       <p:ext uri="{BB962C8B-B14F-4D97-AF65-F5344CB8AC3E}">
         <p14:creationId xmlns:p14="http://schemas.microsoft.com/office/powerpoint/2010/main" val="2213454401"/>
-      </p:ext>
-    </p:extLst>
-  </p:cSld>
-  <p:clrMapOvr>
-    <a:masterClrMapping/>
-  </p:clrMapOvr>
-</p:sld>
-</file>
-
-<file path=ppt/slides/slide2.xml><?xml version="1.0" encoding="utf-8"?>
-<p:sld xmlns:a="http://schemas.openxmlformats.org/drawingml/2006/main" xmlns:r="http://schemas.openxmlformats.org/officeDocument/2006/relationships" xmlns:p="http://schemas.openxmlformats.org/presentationml/2006/main">
-  <p:cSld>
-    <p:spTree>
-      <p:nvGrpSpPr>
-        <p:cNvPr id="1" name=""/>
-        <p:cNvGrpSpPr/>
-        <p:nvPr/>
-      </p:nvGrpSpPr>
-      <p:grpSpPr>
-        <a:xfrm>
-          <a:off x="0" y="0"/>
-          <a:ext cx="0" cy="0"/>
-          <a:chOff x="0" y="0"/>
-          <a:chExt cx="0" cy="0"/>
-        </a:xfrm>
-      </p:grpSpPr>
-      <p:sp>
-        <p:nvSpPr>
-          <p:cNvPr id="4" name="Title 3">
-            <a:extLst>
-              <a:ext uri="{FF2B5EF4-FFF2-40B4-BE49-F238E27FC236}">
-                <a16:creationId xmlns:a16="http://schemas.microsoft.com/office/drawing/2014/main" id="{674358EA-4D5B-461F-997D-DE6729900DE7}"/>
-              </a:ext>
-            </a:extLst>
-          </p:cNvPr>
-          <p:cNvSpPr>
-            <a:spLocks noGrp="1"/>
-          </p:cNvSpPr>
-          <p:nvPr>
-            <p:ph type="ctrTitle"/>
-          </p:nvPr>
-        </p:nvSpPr>
-        <p:spPr/>
-        <p:txBody>
-          <a:bodyPr/>
-          <a:lstStyle/>
-          <a:p>
-            <a:r>
-              <a:rPr lang="en-US" dirty="0"/>
-              <a:t>Scaling methods for QTM</a:t>
-            </a:r>
-            <a:endParaRPr lang="en-GB" dirty="0"/>
-          </a:p>
-        </p:txBody>
-      </p:sp>
-      <p:sp>
-        <p:nvSpPr>
-          <p:cNvPr id="5" name="Subtitle 4">
-            <a:extLst>
-              <a:ext uri="{FF2B5EF4-FFF2-40B4-BE49-F238E27FC236}">
-                <a16:creationId xmlns:a16="http://schemas.microsoft.com/office/drawing/2014/main" id="{88CE6942-A17C-4247-86C6-41FACF7E90AC}"/>
-              </a:ext>
-            </a:extLst>
-          </p:cNvPr>
-          <p:cNvSpPr>
-            <a:spLocks noGrp="1"/>
-          </p:cNvSpPr>
-          <p:nvPr>
-            <p:ph type="subTitle" idx="1"/>
-          </p:nvPr>
-        </p:nvSpPr>
-        <p:spPr/>
-        <p:txBody>
-          <a:bodyPr/>
-          <a:lstStyle/>
-          <a:p>
-            <a:endParaRPr lang="en-GB" dirty="0"/>
-          </a:p>
-        </p:txBody>
-      </p:sp>
-      <p:sp>
-        <p:nvSpPr>
-          <p:cNvPr id="2" name="Footer Placeholder 1">
-            <a:extLst>
-              <a:ext uri="{FF2B5EF4-FFF2-40B4-BE49-F238E27FC236}">
-                <a16:creationId xmlns:a16="http://schemas.microsoft.com/office/drawing/2014/main" id="{A45995EB-10E4-4119-B468-5CD7D10A0933}"/>
-              </a:ext>
-            </a:extLst>
-          </p:cNvPr>
-          <p:cNvSpPr>
-            <a:spLocks noGrp="1"/>
-          </p:cNvSpPr>
-          <p:nvPr>
-            <p:ph type="ftr" sz="quarter" idx="16"/>
-          </p:nvPr>
-        </p:nvSpPr>
-        <p:spPr/>
-        <p:txBody>
-          <a:bodyPr/>
-          <a:lstStyle/>
-          <a:p>
-            <a:r>
-              <a:rPr lang="en-GB"/>
-              <a:t>Title</a:t>
-            </a:r>
-            <a:endParaRPr lang="en-GB" dirty="0"/>
-          </a:p>
-        </p:txBody>
-      </p:sp>
-      <p:sp>
-        <p:nvSpPr>
-          <p:cNvPr id="3" name="Slide Number Placeholder 2">
-            <a:extLst>
-              <a:ext uri="{FF2B5EF4-FFF2-40B4-BE49-F238E27FC236}">
-                <a16:creationId xmlns:a16="http://schemas.microsoft.com/office/drawing/2014/main" id="{0AA221E4-1851-497D-90EE-984C7112166A}"/>
-              </a:ext>
-            </a:extLst>
-          </p:cNvPr>
-          <p:cNvSpPr>
-            <a:spLocks noGrp="1"/>
-          </p:cNvSpPr>
-          <p:nvPr>
-            <p:ph type="sldNum" sz="quarter" idx="17"/>
-          </p:nvPr>
-        </p:nvSpPr>
-        <p:spPr/>
-        <p:txBody>
-          <a:bodyPr/>
-          <a:lstStyle/>
-          <a:p>
-            <a:fld id="{24C8C45C-947F-4981-8B3F-4F32E973C901}" type="slidenum">
-              <a:rPr lang="en-GB" smtClean="0"/>
-              <a:pPr/>
-              <a:t>2</a:t>
-            </a:fld>
-            <a:endParaRPr lang="en-GB" dirty="0"/>
-          </a:p>
-        </p:txBody>
-      </p:sp>
-      <p:sp>
-        <p:nvSpPr>
-          <p:cNvPr id="6" name="Date Placeholder 5">
-            <a:extLst>
-              <a:ext uri="{FF2B5EF4-FFF2-40B4-BE49-F238E27FC236}">
-                <a16:creationId xmlns:a16="http://schemas.microsoft.com/office/drawing/2014/main" id="{6BD79507-030C-48B9-4B06-13AEB08862A3}"/>
-              </a:ext>
-            </a:extLst>
-          </p:cNvPr>
-          <p:cNvSpPr>
-            <a:spLocks noGrp="1"/>
-          </p:cNvSpPr>
-          <p:nvPr>
-            <p:ph type="dt" sz="half" idx="18"/>
-          </p:nvPr>
-        </p:nvSpPr>
-        <p:spPr/>
-        <p:txBody>
-          <a:bodyPr/>
-          <a:lstStyle/>
-          <a:p>
-            <a:r>
-              <a:rPr lang="da-DK"/>
-              <a:t>Date</a:t>
-            </a:r>
-            <a:endParaRPr lang="en-GB"/>
-          </a:p>
-        </p:txBody>
-      </p:sp>
-    </p:spTree>
-    <p:custDataLst>
-      <p:custData r:id="rId1"/>
-      <p:custData r:id="rId2"/>
-    </p:custDataLst>
-    <p:extLst>
-      <p:ext uri="{BB962C8B-B14F-4D97-AF65-F5344CB8AC3E}">
-        <p14:creationId xmlns:p14="http://schemas.microsoft.com/office/powerpoint/2010/main" val="2320714135"/>
       </p:ext>
     </p:extLst>
   </p:cSld>
@@ -16493,25 +16769,6 @@
 </file>
 
 <file path=customXml/item1.xml><?xml version="1.0" encoding="utf-8"?>
-<TemplafySlideTemplateConfiguration><![CDATA[{"elementsMetadata":[],"documentContentValidatorConfiguration":{"enableDocumentContentValidator":false,"documentContentValidatorVersion":0},"slideId":"636957682264057965","enableDocumentContentUpdater":true,"version":"1.2"}]]></TemplafySlideTemplateConfiguration>
-</file>
-
-<file path=customXml/item10.xml><?xml version="1.0" encoding="utf-8"?>
-<p:properties xmlns:p="http://schemas.microsoft.com/office/2006/metadata/properties" xmlns:xsi="http://www.w3.org/2001/XMLSchema-instance" xmlns:pc="http://schemas.microsoft.com/office/infopath/2007/PartnerControls">
-  <documentManagement/>
-</p:properties>
-</file>
-
-<file path=customXml/item11.xml><?xml version="1.0" encoding="utf-8"?>
-<?mso-contentType ?>
-<FormTemplates xmlns="http://schemas.microsoft.com/sharepoint/v3/contenttype/forms">
-  <Display>DocumentLibraryForm</Display>
-  <Edit>DocumentLibraryForm</Edit>
-  <New>DocumentLibraryForm</New>
-</FormTemplates>
-</file>
-
-<file path=customXml/item2.xml><?xml version="1.0" encoding="utf-8"?>
 <ct:contentTypeSchema xmlns:ct="http://schemas.microsoft.com/office/2006/metadata/contentType" xmlns:ma="http://schemas.microsoft.com/office/2006/metadata/properties/metaAttributes" ct:_="" ma:_="" ma:contentTypeName="Document" ma:contentTypeID="0x0101009ADA1FD2B40FDA458284BB6FCA763489" ma:contentTypeVersion="5" ma:contentTypeDescription="Create a new document." ma:contentTypeScope="" ma:versionID="72b2569ebc96083092f6d8e76413cd52">
   <xsd:schema xmlns:xsd="http://www.w3.org/2001/XMLSchema" xmlns:xs="http://www.w3.org/2001/XMLSchema" xmlns:p="http://schemas.microsoft.com/office/2006/metadata/properties" xmlns:ns2="683dcda1-f8c3-442f-ae64-e236c052732d" xmlns:ns3="715bde23-c48d-41ea-a697-dffaa8fbae8d" targetNamespace="http://schemas.microsoft.com/office/2006/metadata/properties" ma:root="true" ma:fieldsID="df14c340b530a7b5c38005fefa6a5693" ns2:_="" ns3:_="">
     <xsd:import namespace="683dcda1-f8c3-442f-ae64-e236c052732d"/>
@@ -16682,12 +16939,29 @@
 </ct:contentTypeSchema>
 </file>
 
-<file path=customXml/item3.xml><?xml version="1.0" encoding="utf-8"?>
+<file path=customXml/item10.xml><?xml version="1.0" encoding="utf-8"?>
 <TemplafyTemplateConfiguration><![CDATA[{"elementsMetadata":[],"transformationConfigurations":[{"language":"{{DocumentLanguage}}","disableUpdates":false,"type":"proofingLanguage"}],"templateName":"DTU Template 16_9 - Purple","templateDescription":"","enableDocumentContentUpdater":true,"version":"1.2"}]]></TemplafyTemplateConfiguration>
 </file>
 
+<file path=customXml/item11.xml><?xml version="1.0" encoding="utf-8"?>
+<TemplafySlideFormConfiguration><![CDATA[{"formFields":[],"formDataEntries":[]}]]></TemplafySlideFormConfiguration>
+</file>
+
+<file path=customXml/item2.xml><?xml version="1.0" encoding="utf-8"?>
+<TemplafySlideTemplateConfiguration><![CDATA[{"elementsMetadata":[],"documentContentValidatorConfiguration":{"enableDocumentContentValidator":false,"documentContentValidatorVersion":0},"slideId":"636957682264057965","enableDocumentContentUpdater":true,"version":"1.2"}]]></TemplafySlideTemplateConfiguration>
+</file>
+
+<file path=customXml/item3.xml><?xml version="1.0" encoding="utf-8"?>
+<TemplafySlideFormConfiguration><![CDATA[{"formFields":[],"formDataEntries":[]}]]></TemplafySlideFormConfiguration>
+</file>
+
 <file path=customXml/item4.xml><?xml version="1.0" encoding="utf-8"?>
-<TemplafySlideTemplateConfiguration><![CDATA[{"elementsMetadata":[],"documentContentValidatorConfiguration":{"enableDocumentContentValidator":false,"documentContentValidatorVersion":0},"slideId":"636957682264370159","enableDocumentContentUpdater":true,"version":"1.2"}]]></TemplafySlideTemplateConfiguration>
+<?mso-contentType ?>
+<FormTemplates xmlns="http://schemas.microsoft.com/sharepoint/v3/contenttype/forms">
+  <Display>DocumentLibraryForm</Display>
+  <Edit>DocumentLibraryForm</Edit>
+  <New>DocumentLibraryForm</New>
+</FormTemplates>
 </file>
 
 <file path=customXml/item5.xml><?xml version="1.0" encoding="utf-8"?>
@@ -16695,45 +16969,24 @@
 </file>
 
 <file path=customXml/item6.xml><?xml version="1.0" encoding="utf-8"?>
+<p:properties xmlns:p="http://schemas.microsoft.com/office/2006/metadata/properties" xmlns:xsi="http://www.w3.org/2001/XMLSchema-instance" xmlns:pc="http://schemas.microsoft.com/office/infopath/2007/PartnerControls">
+  <documentManagement/>
+</p:properties>
+</file>
+
+<file path=customXml/item7.xml><?xml version="1.0" encoding="utf-8"?>
+<TemplafySlideTemplateConfiguration><![CDATA[{"elementsMetadata":[],"documentContentValidatorConfiguration":{"enableDocumentContentValidator":false,"documentContentValidatorVersion":0},"slideId":"636957682264370159","enableDocumentContentUpdater":true,"version":"1.2"}]]></TemplafySlideTemplateConfiguration>
+</file>
+
+<file path=customXml/item8.xml><?xml version="1.0" encoding="utf-8"?>
+<TemplafyFormConfiguration><![CDATA[{"formFields":[{"required":false,"type":"datePicker","name":"Date","label":"Date","helpTexts":{"prefix":"","postfix":""},"spacing":{},"fullyQualifiedName":"Date"},{"required":false,"placeholder":"","lines":0,"type":"textBox","name":"PresentationTitle","label":"Presentation title","helpTexts":{"prefix":"","postfix":""},"spacing":{},"fullyQualifiedName":"PresentationTitle"}],"formDataEntries":[]}]]></TemplafyFormConfiguration>
+</file>
+
+<file path=customXml/item9.xml><?xml version="1.0" encoding="utf-8"?>
 <TemplafySlideFormConfiguration><![CDATA[{"formFields":[],"formDataEntries":[]}]]></TemplafySlideFormConfiguration>
 </file>
 
-<file path=customXml/item7.xml><?xml version="1.0" encoding="utf-8"?>
-<TemplafySlideFormConfiguration><![CDATA[{"formFields":[],"formDataEntries":[]}]]></TemplafySlideFormConfiguration>
-</file>
-
-<file path=customXml/item8.xml><?xml version="1.0" encoding="utf-8"?>
-<TemplafySlideFormConfiguration><![CDATA[{"formFields":[],"formDataEntries":[]}]]></TemplafySlideFormConfiguration>
-</file>
-
-<file path=customXml/item9.xml><?xml version="1.0" encoding="utf-8"?>
-<TemplafyFormConfiguration><![CDATA[{"formFields":[{"required":false,"type":"datePicker","name":"Date","label":"Date","helpTexts":{"prefix":"","postfix":""},"spacing":{},"fullyQualifiedName":"Date"},{"required":false,"placeholder":"","lines":0,"type":"textBox","name":"PresentationTitle","label":"Presentation title","helpTexts":{"prefix":"","postfix":""},"spacing":{},"fullyQualifiedName":"PresentationTitle"}],"formDataEntries":[]}]]></TemplafyFormConfiguration>
-</file>
-
 <file path=customXml/itemProps1.xml><?xml version="1.0" encoding="utf-8"?>
-<ds:datastoreItem xmlns:ds="http://schemas.openxmlformats.org/officeDocument/2006/customXml" ds:itemID="{ECA1DA60-FB17-4EB5-97F4-62F99A1A733D}">
-  <ds:schemaRefs/>
-</ds:datastoreItem>
-</file>
-
-<file path=customXml/itemProps10.xml><?xml version="1.0" encoding="utf-8"?>
-<ds:datastoreItem xmlns:ds="http://schemas.openxmlformats.org/officeDocument/2006/customXml" ds:itemID="{C7696DC1-7A22-4198-A4D1-783EAEBC6DD4}">
-  <ds:schemaRefs>
-    <ds:schemaRef ds:uri="http://schemas.microsoft.com/office/2006/metadata/properties"/>
-    <ds:schemaRef ds:uri="http://schemas.microsoft.com/office/infopath/2007/PartnerControls"/>
-  </ds:schemaRefs>
-</ds:datastoreItem>
-</file>
-
-<file path=customXml/itemProps11.xml><?xml version="1.0" encoding="utf-8"?>
-<ds:datastoreItem xmlns:ds="http://schemas.openxmlformats.org/officeDocument/2006/customXml" ds:itemID="{3FAD9687-A325-465A-822F-98C7D264CFD7}">
-  <ds:schemaRefs>
-    <ds:schemaRef ds:uri="http://schemas.microsoft.com/sharepoint/v3/contenttype/forms"/>
-  </ds:schemaRefs>
-</ds:datastoreItem>
-</file>
-
-<file path=customXml/itemProps2.xml><?xml version="1.0" encoding="utf-8"?>
 <ds:datastoreItem xmlns:ds="http://schemas.openxmlformats.org/officeDocument/2006/customXml" ds:itemID="{9F0C0281-0754-4C07-B1CB-D9771AB751DC}">
   <ds:schemaRefs>
     <ds:schemaRef ds:uri="http://schemas.microsoft.com/office/2006/metadata/contentType"/>
@@ -16752,15 +17005,35 @@
 </ds:datastoreItem>
 </file>
 
-<file path=customXml/itemProps3.xml><?xml version="1.0" encoding="utf-8"?>
+<file path=customXml/itemProps10.xml><?xml version="1.0" encoding="utf-8"?>
 <ds:datastoreItem xmlns:ds="http://schemas.openxmlformats.org/officeDocument/2006/customXml" ds:itemID="{1334258C-C3E7-4029-A615-C886A240FB15}">
   <ds:schemaRefs/>
 </ds:datastoreItem>
 </file>
 
+<file path=customXml/itemProps11.xml><?xml version="1.0" encoding="utf-8"?>
+<ds:datastoreItem xmlns:ds="http://schemas.openxmlformats.org/officeDocument/2006/customXml" ds:itemID="{A24B75EB-8202-4907-9D1E-5F9CF0C29483}">
+  <ds:schemaRefs/>
+</ds:datastoreItem>
+</file>
+
+<file path=customXml/itemProps2.xml><?xml version="1.0" encoding="utf-8"?>
+<ds:datastoreItem xmlns:ds="http://schemas.openxmlformats.org/officeDocument/2006/customXml" ds:itemID="{ECA1DA60-FB17-4EB5-97F4-62F99A1A733D}">
+  <ds:schemaRefs/>
+</ds:datastoreItem>
+</file>
+
+<file path=customXml/itemProps3.xml><?xml version="1.0" encoding="utf-8"?>
+<ds:datastoreItem xmlns:ds="http://schemas.openxmlformats.org/officeDocument/2006/customXml" ds:itemID="{E618FA3B-8A67-40AE-8AE5-229504AB69D3}">
+  <ds:schemaRefs/>
+</ds:datastoreItem>
+</file>
+
 <file path=customXml/itemProps4.xml><?xml version="1.0" encoding="utf-8"?>
-<ds:datastoreItem xmlns:ds="http://schemas.openxmlformats.org/officeDocument/2006/customXml" ds:itemID="{3DB14396-8B0C-45B4-9B8F-11E9F605DE89}">
-  <ds:schemaRefs/>
+<ds:datastoreItem xmlns:ds="http://schemas.openxmlformats.org/officeDocument/2006/customXml" ds:itemID="{3FAD9687-A325-465A-822F-98C7D264CFD7}">
+  <ds:schemaRefs>
+    <ds:schemaRef ds:uri="http://schemas.microsoft.com/sharepoint/v3/contenttype/forms"/>
+  </ds:schemaRefs>
 </ds:datastoreItem>
 </file>
 
@@ -16771,25 +17044,28 @@
 </file>
 
 <file path=customXml/itemProps6.xml><?xml version="1.0" encoding="utf-8"?>
-<ds:datastoreItem xmlns:ds="http://schemas.openxmlformats.org/officeDocument/2006/customXml" ds:itemID="{E618FA3B-8A67-40AE-8AE5-229504AB69D3}">
-  <ds:schemaRefs/>
+<ds:datastoreItem xmlns:ds="http://schemas.openxmlformats.org/officeDocument/2006/customXml" ds:itemID="{C7696DC1-7A22-4198-A4D1-783EAEBC6DD4}">
+  <ds:schemaRefs>
+    <ds:schemaRef ds:uri="http://schemas.microsoft.com/office/2006/metadata/properties"/>
+    <ds:schemaRef ds:uri="http://schemas.microsoft.com/office/infopath/2007/PartnerControls"/>
+  </ds:schemaRefs>
 </ds:datastoreItem>
 </file>
 
 <file path=customXml/itemProps7.xml><?xml version="1.0" encoding="utf-8"?>
-<ds:datastoreItem xmlns:ds="http://schemas.openxmlformats.org/officeDocument/2006/customXml" ds:itemID="{A24B75EB-8202-4907-9D1E-5F9CF0C29483}">
+<ds:datastoreItem xmlns:ds="http://schemas.openxmlformats.org/officeDocument/2006/customXml" ds:itemID="{3DB14396-8B0C-45B4-9B8F-11E9F605DE89}">
   <ds:schemaRefs/>
 </ds:datastoreItem>
 </file>
 
 <file path=customXml/itemProps8.xml><?xml version="1.0" encoding="utf-8"?>
-<ds:datastoreItem xmlns:ds="http://schemas.openxmlformats.org/officeDocument/2006/customXml" ds:itemID="{403BE795-51D5-47B5-B747-A10BFE22AFA8}">
+<ds:datastoreItem xmlns:ds="http://schemas.openxmlformats.org/officeDocument/2006/customXml" ds:itemID="{69ED2CA6-29BB-4407-9012-18ED2ECCD16E}">
   <ds:schemaRefs/>
 </ds:datastoreItem>
 </file>
 
 <file path=customXml/itemProps9.xml><?xml version="1.0" encoding="utf-8"?>
-<ds:datastoreItem xmlns:ds="http://schemas.openxmlformats.org/officeDocument/2006/customXml" ds:itemID="{69ED2CA6-29BB-4407-9012-18ED2ECCD16E}">
+<ds:datastoreItem xmlns:ds="http://schemas.openxmlformats.org/officeDocument/2006/customXml" ds:itemID="{403BE795-51D5-47B5-B747-A10BFE22AFA8}">
   <ds:schemaRefs/>
 </ds:datastoreItem>
 </file>
</xml_diff>